<commit_message>
Style slide 2 (2026 forecast) to match slide 1's design language
Apply the navy/light-gray/muted blue-gray palette already established
on slide 1 to the previously-default table and chart on slide 2:
navy header row with white text, subtle gray row dividers, a
distinct light-navy total row with a bold top rule, and navy/amber
conditional coloring on the ביצוע % column. The 3-bar budget/target/
actual chart gets a light-gray-to-navy gradient (reusing slide 1's
exact bar colors), bold value labels, and horizontal category labels.
Restyled the bottom stat line to match slide 1's big-number/muted-label
hierarchy. Slide 1 and its chart are untouched (verified byte-identical).

Co-Authored-By: Claude Sonnet 5 <noreply@anthropic.com>
Claude-Session: https://claude.ai/code/session_01E9QvuhBZminJvrtKVH8YY8
</commit_message>
<xml_diff>
--- a/svetlana/outputs/2026-10-27-מכירות-סטטוס-ותחזית-2026.pptx
+++ b/svetlana/outputs/2026-10-27-מכירות-סטטוס-ותחזית-2026.pptx
@@ -691,7 +691,47 @@
             <a:effectLst/>
           </c:spPr>
           <c:invertIfNegative val="0"/>
+          <c:dPt>
+            <c:idx val="0"/>
+            <c:invertIfNegative val="0"/>
+            <c:spPr>
+              <a:solidFill>
+                <a:srgbClr val="D9D9D9"/>
+              </a:solidFill>
+              <a:ln>
+                <a:noFill/>
+              </a:ln>
+              <a:effectLst/>
+            </c:spPr>
+          </c:dPt>
+          <c:dPt>
+            <c:idx val="1"/>
+            <c:invertIfNegative val="0"/>
+            <c:spPr>
+              <a:solidFill>
+                <a:srgbClr val="5B6B82"/>
+              </a:solidFill>
+              <a:ln>
+                <a:noFill/>
+              </a:ln>
+              <a:effectLst/>
+            </c:spPr>
+          </c:dPt>
+          <c:dPt>
+            <c:idx val="2"/>
+            <c:invertIfNegative val="0"/>
+            <c:spPr>
+              <a:solidFill>
+                <a:srgbClr val="002F6C"/>
+              </a:solidFill>
+              <a:ln>
+                <a:noFill/>
+              </a:ln>
+              <a:effectLst/>
+            </c:spPr>
+          </c:dPt>
           <c:dLbls>
+            <c:numFmt formatCode="0.0&quot;M&quot;" sourceLinked="0"/>
             <c:spPr>
               <a:noFill/>
               <a:ln>
@@ -706,12 +746,9 @@
               <a:lstStyle/>
               <a:p>
                 <a:pPr>
-                  <a:defRPr sz="900" b="0" i="0" u="none" strike="noStrike" kern="1200" baseline="0">
+                  <a:defRPr sz="1000" b="1" i="0" u="none" strike="noStrike" kern="1200" baseline="0">
                     <a:solidFill>
-                      <a:schemeClr val="tx1">
-                        <a:lumMod val="75000"/>
-                        <a:lumOff val="25000"/>
-                      </a:schemeClr>
+                      <a:srgbClr val="002F6C"/>
                     </a:solidFill>
                     <a:latin typeface="+mn-lt"/>
                     <a:ea typeface="+mn-ea"/>
@@ -798,7 +835,7 @@
           <c:showPercent val="0"/>
           <c:showBubbleSize val="0"/>
         </c:dLbls>
-        <c:gapWidth val="219"/>
+        <c:gapWidth val="80"/>
         <c:overlap val="-27"/>
         <c:axId val="956399088"/>
         <c:axId val="956398008"/>
@@ -818,26 +855,20 @@
           <a:noFill/>
           <a:ln w="9525" cap="flat" cmpd="sng" algn="ctr">
             <a:solidFill>
-              <a:schemeClr val="tx1">
-                <a:lumMod val="15000"/>
-                <a:lumOff val="85000"/>
-              </a:schemeClr>
+              <a:srgbClr val="D9D9D9"/>
             </a:solidFill>
             <a:round/>
           </a:ln>
           <a:effectLst/>
         </c:spPr>
         <c:txPr>
-          <a:bodyPr rot="-60000000" spcFirstLastPara="1" vertOverflow="ellipsis" vert="horz" wrap="square" anchor="ctr" anchorCtr="1"/>
+          <a:bodyPr rot="0" spcFirstLastPara="1" vertOverflow="ellipsis" vert="horz" wrap="square" anchor="ctr" anchorCtr="1"/>
           <a:lstStyle/>
           <a:p>
             <a:pPr>
-              <a:defRPr sz="900" b="0" i="0" u="none" strike="noStrike" kern="1200" baseline="0">
+              <a:defRPr sz="950" b="0" i="0" u="none" strike="noStrike" kern="1200" baseline="0">
                 <a:solidFill>
-                  <a:schemeClr val="tx1">
-                    <a:lumMod val="65000"/>
-                    <a:lumOff val="35000"/>
-                  </a:schemeClr>
+                  <a:srgbClr val="5B6B82"/>
                 </a:solidFill>
                 <a:latin typeface="+mn-lt"/>
                 <a:ea typeface="+mn-ea"/>
@@ -4232,36 +4263,36 @@
           </p:nvPr>
         </p:nvGraphicFramePr>
         <p:xfrm>
-          <a:off x="8261927" y="1434017"/>
-          <a:ext cx="2743200" cy="2543175"/>
+          <a:off x="7500000" y="1434017"/>
+          <a:ext cx="4200000" cy="2543175"/>
         </p:xfrm>
         <a:graphic>
           <a:graphicData uri="http://schemas.openxmlformats.org/drawingml/2006/table">
             <a:tbl>
               <a:tblPr rtl="1"/>
               <a:tblGrid>
-                <a:gridCol w="685800">
+                <a:gridCol w="1600200">
                   <a:extLst>
                     <a:ext uri="{9D8B030D-6E8A-4147-A177-3AD203B41FA5}">
                       <a16:colId xmlns:a16="http://schemas.microsoft.com/office/drawing/2014/main" val="2423334984"/>
                     </a:ext>
                   </a:extLst>
                 </a:gridCol>
-                <a:gridCol w="685800">
+                <a:gridCol w="866600">
                   <a:extLst>
                     <a:ext uri="{9D8B030D-6E8A-4147-A177-3AD203B41FA5}">
                       <a16:colId xmlns:a16="http://schemas.microsoft.com/office/drawing/2014/main" val="4285592505"/>
                     </a:ext>
                   </a:extLst>
                 </a:gridCol>
-                <a:gridCol w="685800">
+                <a:gridCol w="866600">
                   <a:extLst>
                     <a:ext uri="{9D8B030D-6E8A-4147-A177-3AD203B41FA5}">
                       <a16:colId xmlns:a16="http://schemas.microsoft.com/office/drawing/2014/main" val="2503073280"/>
                     </a:ext>
                   </a:extLst>
                 </a:gridCol>
-                <a:gridCol w="685800">
+                <a:gridCol w="866600">
                   <a:extLst>
                     <a:ext uri="{9D8B030D-6E8A-4147-A177-3AD203B41FA5}">
                       <a16:colId xmlns:a16="http://schemas.microsoft.com/office/drawing/2014/main" val="3193351712"/>
@@ -4281,7 +4312,7 @@
                       <a:r>
                         <a:rPr lang="he-IL" sz="1000" b="1" i="0" u="none" strike="noStrike" dirty="0">
                           <a:solidFill>
-                            <a:srgbClr val="000000"/>
+                            <a:srgbClr val="FFFFFF"/>
                           </a:solidFill>
                           <a:effectLst/>
                           <a:latin typeface="Arial" panose="020B0604020202020204" pitchFamily="34" charset="0"/>
@@ -4293,7 +4324,7 @@
                   <a:tcPr marL="9525" marR="9525" marT="9525" marB="0" anchor="b">
                     <a:lnL w="6350" cap="flat" cmpd="sng" algn="ctr">
                       <a:solidFill>
-                        <a:srgbClr val="000000"/>
+                        <a:srgbClr val="002F6C"/>
                       </a:solidFill>
                       <a:prstDash val="solid"/>
                       <a:round/>
@@ -4302,7 +4333,7 @@
                     </a:lnL>
                     <a:lnR w="6350" cap="flat" cmpd="sng" algn="ctr">
                       <a:solidFill>
-                        <a:srgbClr val="000000"/>
+                        <a:srgbClr val="002F6C"/>
                       </a:solidFill>
                       <a:prstDash val="solid"/>
                       <a:round/>
@@ -4311,7 +4342,7 @@
                     </a:lnR>
                     <a:lnT w="6350" cap="flat" cmpd="sng" algn="ctr">
                       <a:solidFill>
-                        <a:srgbClr val="000000"/>
+                        <a:srgbClr val="002F6C"/>
                       </a:solidFill>
                       <a:prstDash val="solid"/>
                       <a:round/>
@@ -4320,7 +4351,7 @@
                     </a:lnT>
                     <a:lnB w="6350" cap="flat" cmpd="sng" algn="ctr">
                       <a:solidFill>
-                        <a:srgbClr val="000000"/>
+                        <a:srgbClr val="002F6C"/>
                       </a:solidFill>
                       <a:prstDash val="solid"/>
                       <a:round/>
@@ -4328,7 +4359,7 @@
                       <a:tailEnd type="none" w="med" len="med"/>
                     </a:lnB>
                     <a:solidFill>
-                      <a:srgbClr val="C0E6F5"/>
+                      <a:srgbClr val="002F6C"/>
                     </a:solidFill>
                   </a:tcPr>
                 </a:tc>
@@ -4343,7 +4374,7 @@
                       <a:r>
                         <a:rPr lang="he-IL" sz="1000" b="1" i="0" u="none" strike="noStrike" dirty="0">
                           <a:solidFill>
-                            <a:srgbClr val="000000"/>
+                            <a:srgbClr val="FFFFFF"/>
                           </a:solidFill>
                           <a:effectLst/>
                           <a:latin typeface="Arial" panose="020B0604020202020204" pitchFamily="34" charset="0"/>
@@ -4355,7 +4386,7 @@
                   <a:tcPr marL="9525" marR="9525" marT="9525" marB="0" anchor="b">
                     <a:lnL w="6350" cap="flat" cmpd="sng" algn="ctr">
                       <a:solidFill>
-                        <a:srgbClr val="000000"/>
+                        <a:srgbClr val="002F6C"/>
                       </a:solidFill>
                       <a:prstDash val="solid"/>
                       <a:round/>
@@ -4364,7 +4395,7 @@
                     </a:lnL>
                     <a:lnR w="6350" cap="flat" cmpd="sng" algn="ctr">
                       <a:solidFill>
-                        <a:srgbClr val="000000"/>
+                        <a:srgbClr val="002F6C"/>
                       </a:solidFill>
                       <a:prstDash val="solid"/>
                       <a:round/>
@@ -4373,7 +4404,7 @@
                     </a:lnR>
                     <a:lnT w="6350" cap="flat" cmpd="sng" algn="ctr">
                       <a:solidFill>
-                        <a:srgbClr val="000000"/>
+                        <a:srgbClr val="002F6C"/>
                       </a:solidFill>
                       <a:prstDash val="solid"/>
                       <a:round/>
@@ -4382,7 +4413,7 @@
                     </a:lnT>
                     <a:lnB w="6350" cap="flat" cmpd="sng" algn="ctr">
                       <a:solidFill>
-                        <a:srgbClr val="000000"/>
+                        <a:srgbClr val="002F6C"/>
                       </a:solidFill>
                       <a:prstDash val="solid"/>
                       <a:round/>
@@ -4390,7 +4421,7 @@
                       <a:tailEnd type="none" w="med" len="med"/>
                     </a:lnB>
                     <a:solidFill>
-                      <a:srgbClr val="C0E6F5"/>
+                      <a:srgbClr val="002F6C"/>
                     </a:solidFill>
                   </a:tcPr>
                 </a:tc>
@@ -4405,7 +4436,7 @@
                       <a:r>
                         <a:rPr lang="he-IL" sz="1000" b="1" i="0" u="none" strike="noStrike">
                           <a:solidFill>
-                            <a:srgbClr val="000000"/>
+                            <a:srgbClr val="FFFFFF"/>
                           </a:solidFill>
                           <a:effectLst/>
                           <a:latin typeface="Arial" panose="020B0604020202020204" pitchFamily="34" charset="0"/>
@@ -4417,7 +4448,7 @@
                   <a:tcPr marL="9525" marR="9525" marT="9525" marB="0" anchor="b">
                     <a:lnL w="6350" cap="flat" cmpd="sng" algn="ctr">
                       <a:solidFill>
-                        <a:srgbClr val="000000"/>
+                        <a:srgbClr val="002F6C"/>
                       </a:solidFill>
                       <a:prstDash val="solid"/>
                       <a:round/>
@@ -4426,7 +4457,7 @@
                     </a:lnL>
                     <a:lnR w="6350" cap="flat" cmpd="sng" algn="ctr">
                       <a:solidFill>
-                        <a:srgbClr val="000000"/>
+                        <a:srgbClr val="002F6C"/>
                       </a:solidFill>
                       <a:prstDash val="solid"/>
                       <a:round/>
@@ -4435,7 +4466,7 @@
                     </a:lnR>
                     <a:lnT w="6350" cap="flat" cmpd="sng" algn="ctr">
                       <a:solidFill>
-                        <a:srgbClr val="000000"/>
+                        <a:srgbClr val="002F6C"/>
                       </a:solidFill>
                       <a:prstDash val="solid"/>
                       <a:round/>
@@ -4444,7 +4475,7 @@
                     </a:lnT>
                     <a:lnB w="6350" cap="flat" cmpd="sng" algn="ctr">
                       <a:solidFill>
-                        <a:srgbClr val="000000"/>
+                        <a:srgbClr val="002F6C"/>
                       </a:solidFill>
                       <a:prstDash val="solid"/>
                       <a:round/>
@@ -4452,7 +4483,7 @@
                       <a:tailEnd type="none" w="med" len="med"/>
                     </a:lnB>
                     <a:solidFill>
-                      <a:srgbClr val="C0E6F5"/>
+                      <a:srgbClr val="002F6C"/>
                     </a:solidFill>
                   </a:tcPr>
                 </a:tc>
@@ -4467,7 +4498,7 @@
                       <a:r>
                         <a:rPr lang="he-IL" sz="1000" b="1" i="0" u="none" strike="noStrike">
                           <a:solidFill>
-                            <a:srgbClr val="000000"/>
+                            <a:srgbClr val="FFFFFF"/>
                           </a:solidFill>
                           <a:effectLst/>
                           <a:latin typeface="Arial" panose="020B0604020202020204" pitchFamily="34" charset="0"/>
@@ -4479,7 +4510,7 @@
                   <a:tcPr marL="9525" marR="9525" marT="9525" marB="0" anchor="b">
                     <a:lnL w="6350" cap="flat" cmpd="sng" algn="ctr">
                       <a:solidFill>
-                        <a:srgbClr val="000000"/>
+                        <a:srgbClr val="002F6C"/>
                       </a:solidFill>
                       <a:prstDash val="solid"/>
                       <a:round/>
@@ -4488,7 +4519,7 @@
                     </a:lnL>
                     <a:lnR w="6350" cap="flat" cmpd="sng" algn="ctr">
                       <a:solidFill>
-                        <a:srgbClr val="000000"/>
+                        <a:srgbClr val="002F6C"/>
                       </a:solidFill>
                       <a:prstDash val="solid"/>
                       <a:round/>
@@ -4497,7 +4528,7 @@
                     </a:lnR>
                     <a:lnT w="6350" cap="flat" cmpd="sng" algn="ctr">
                       <a:solidFill>
-                        <a:srgbClr val="000000"/>
+                        <a:srgbClr val="002F6C"/>
                       </a:solidFill>
                       <a:prstDash val="solid"/>
                       <a:round/>
@@ -4506,7 +4537,7 @@
                     </a:lnT>
                     <a:lnB w="6350" cap="flat" cmpd="sng" algn="ctr">
                       <a:solidFill>
-                        <a:srgbClr val="000000"/>
+                        <a:srgbClr val="002F6C"/>
                       </a:solidFill>
                       <a:prstDash val="solid"/>
                       <a:round/>
@@ -4514,7 +4545,7 @@
                       <a:tailEnd type="none" w="med" len="med"/>
                     </a:lnB>
                     <a:solidFill>
-                      <a:srgbClr val="C0E6F5"/>
+                      <a:srgbClr val="002F6C"/>
                     </a:solidFill>
                   </a:tcPr>
                 </a:tc>
@@ -4555,7 +4586,7 @@
                   <a:tcPr marL="9525" marR="9525" marT="9525" marB="0" anchor="b">
                     <a:lnL w="6350" cap="flat" cmpd="sng" algn="ctr">
                       <a:solidFill>
-                        <a:srgbClr val="000000"/>
+                        <a:srgbClr val="D9D9D9"/>
                       </a:solidFill>
                       <a:prstDash val="solid"/>
                       <a:round/>
@@ -4564,7 +4595,7 @@
                     </a:lnL>
                     <a:lnR w="6350" cap="flat" cmpd="sng" algn="ctr">
                       <a:solidFill>
-                        <a:srgbClr val="000000"/>
+                        <a:srgbClr val="D9D9D9"/>
                       </a:solidFill>
                       <a:prstDash val="solid"/>
                       <a:round/>
@@ -4573,7 +4604,7 @@
                     </a:lnR>
                     <a:lnT w="6350" cap="flat" cmpd="sng" algn="ctr">
                       <a:solidFill>
-                        <a:srgbClr val="000000"/>
+                        <a:srgbClr val="D9D9D9"/>
                       </a:solidFill>
                       <a:prstDash val="solid"/>
                       <a:round/>
@@ -4582,7 +4613,7 @@
                     </a:lnT>
                     <a:lnB w="6350" cap="flat" cmpd="sng" algn="ctr">
                       <a:solidFill>
-                        <a:srgbClr val="000000"/>
+                        <a:srgbClr val="D9D9D9"/>
                       </a:solidFill>
                       <a:prstDash val="solid"/>
                       <a:round/>
@@ -4615,7 +4646,7 @@
                   <a:tcPr marL="9525" marR="9525" marT="9525" marB="0" anchor="b">
                     <a:lnL w="6350" cap="flat" cmpd="sng" algn="ctr">
                       <a:solidFill>
-                        <a:srgbClr val="000000"/>
+                        <a:srgbClr val="D9D9D9"/>
                       </a:solidFill>
                       <a:prstDash val="solid"/>
                       <a:round/>
@@ -4624,7 +4655,7 @@
                     </a:lnL>
                     <a:lnR w="6350" cap="flat" cmpd="sng" algn="ctr">
                       <a:solidFill>
-                        <a:srgbClr val="000000"/>
+                        <a:srgbClr val="D9D9D9"/>
                       </a:solidFill>
                       <a:prstDash val="solid"/>
                       <a:round/>
@@ -4633,7 +4664,7 @@
                     </a:lnR>
                     <a:lnT w="6350" cap="flat" cmpd="sng" algn="ctr">
                       <a:solidFill>
-                        <a:srgbClr val="000000"/>
+                        <a:srgbClr val="D9D9D9"/>
                       </a:solidFill>
                       <a:prstDash val="solid"/>
                       <a:round/>
@@ -4642,7 +4673,7 @@
                     </a:lnT>
                     <a:lnB w="6350" cap="flat" cmpd="sng" algn="ctr">
                       <a:solidFill>
-                        <a:srgbClr val="000000"/>
+                        <a:srgbClr val="D9D9D9"/>
                       </a:solidFill>
                       <a:prstDash val="solid"/>
                       <a:round/>
@@ -4675,7 +4706,7 @@
                   <a:tcPr marL="9525" marR="9525" marT="9525" marB="0" anchor="b">
                     <a:lnL w="6350" cap="flat" cmpd="sng" algn="ctr">
                       <a:solidFill>
-                        <a:srgbClr val="000000"/>
+                        <a:srgbClr val="D9D9D9"/>
                       </a:solidFill>
                       <a:prstDash val="solid"/>
                       <a:round/>
@@ -4684,7 +4715,7 @@
                     </a:lnL>
                     <a:lnR w="6350" cap="flat" cmpd="sng" algn="ctr">
                       <a:solidFill>
-                        <a:srgbClr val="000000"/>
+                        <a:srgbClr val="D9D9D9"/>
                       </a:solidFill>
                       <a:prstDash val="solid"/>
                       <a:round/>
@@ -4693,7 +4724,7 @@
                     </a:lnR>
                     <a:lnT w="6350" cap="flat" cmpd="sng" algn="ctr">
                       <a:solidFill>
-                        <a:srgbClr val="000000"/>
+                        <a:srgbClr val="D9D9D9"/>
                       </a:solidFill>
                       <a:prstDash val="solid"/>
                       <a:round/>
@@ -4702,7 +4733,7 @@
                     </a:lnT>
                     <a:lnB w="6350" cap="flat" cmpd="sng" algn="ctr">
                       <a:solidFill>
-                        <a:srgbClr val="000000"/>
+                        <a:srgbClr val="D9D9D9"/>
                       </a:solidFill>
                       <a:prstDash val="solid"/>
                       <a:round/>
@@ -4721,9 +4752,9 @@
                         <a:buNone/>
                       </a:pPr>
                       <a:r>
-                        <a:rPr lang="he-IL" sz="1000" b="0" i="0" u="none" strike="noStrike">
+                        <a:rPr lang="he-IL" sz="1000" b="1" i="0" u="none" strike="noStrike">
                           <a:solidFill>
-                            <a:srgbClr val="000000"/>
+                            <a:srgbClr val="002F6C"/>
                           </a:solidFill>
                           <a:effectLst/>
                           <a:latin typeface="Arial" panose="020B0604020202020204" pitchFamily="34" charset="0"/>
@@ -4735,7 +4766,7 @@
                   <a:tcPr marL="9525" marR="9525" marT="9525" marB="0" anchor="b">
                     <a:lnL w="6350" cap="flat" cmpd="sng" algn="ctr">
                       <a:solidFill>
-                        <a:srgbClr val="000000"/>
+                        <a:srgbClr val="D9D9D9"/>
                       </a:solidFill>
                       <a:prstDash val="solid"/>
                       <a:round/>
@@ -4744,7 +4775,7 @@
                     </a:lnL>
                     <a:lnR w="6350" cap="flat" cmpd="sng" algn="ctr">
                       <a:solidFill>
-                        <a:srgbClr val="000000"/>
+                        <a:srgbClr val="D9D9D9"/>
                       </a:solidFill>
                       <a:prstDash val="solid"/>
                       <a:round/>
@@ -4753,7 +4784,7 @@
                     </a:lnR>
                     <a:lnT w="6350" cap="flat" cmpd="sng" algn="ctr">
                       <a:solidFill>
-                        <a:srgbClr val="000000"/>
+                        <a:srgbClr val="D9D9D9"/>
                       </a:solidFill>
                       <a:prstDash val="solid"/>
                       <a:round/>
@@ -4762,7 +4793,7 @@
                     </a:lnT>
                     <a:lnB w="6350" cap="flat" cmpd="sng" algn="ctr">
                       <a:solidFill>
-                        <a:srgbClr val="000000"/>
+                        <a:srgbClr val="D9D9D9"/>
                       </a:solidFill>
                       <a:prstDash val="solid"/>
                       <a:round/>
@@ -4802,7 +4833,7 @@
                   <a:tcPr marL="9525" marR="9525" marT="9525" marB="0" anchor="b">
                     <a:lnL w="6350" cap="flat" cmpd="sng" algn="ctr">
                       <a:solidFill>
-                        <a:srgbClr val="000000"/>
+                        <a:srgbClr val="D9D9D9"/>
                       </a:solidFill>
                       <a:prstDash val="solid"/>
                       <a:round/>
@@ -4811,7 +4842,7 @@
                     </a:lnL>
                     <a:lnR w="6350" cap="flat" cmpd="sng" algn="ctr">
                       <a:solidFill>
-                        <a:srgbClr val="000000"/>
+                        <a:srgbClr val="D9D9D9"/>
                       </a:solidFill>
                       <a:prstDash val="solid"/>
                       <a:round/>
@@ -4820,7 +4851,7 @@
                     </a:lnR>
                     <a:lnT w="6350" cap="flat" cmpd="sng" algn="ctr">
                       <a:solidFill>
-                        <a:srgbClr val="000000"/>
+                        <a:srgbClr val="D9D9D9"/>
                       </a:solidFill>
                       <a:prstDash val="solid"/>
                       <a:round/>
@@ -4829,7 +4860,7 @@
                     </a:lnT>
                     <a:lnB w="6350" cap="flat" cmpd="sng" algn="ctr">
                       <a:solidFill>
-                        <a:srgbClr val="000000"/>
+                        <a:srgbClr val="D9D9D9"/>
                       </a:solidFill>
                       <a:prstDash val="solid"/>
                       <a:round/>
@@ -4862,7 +4893,7 @@
                   <a:tcPr marL="9525" marR="9525" marT="9525" marB="0" anchor="b">
                     <a:lnL w="6350" cap="flat" cmpd="sng" algn="ctr">
                       <a:solidFill>
-                        <a:srgbClr val="000000"/>
+                        <a:srgbClr val="D9D9D9"/>
                       </a:solidFill>
                       <a:prstDash val="solid"/>
                       <a:round/>
@@ -4871,7 +4902,7 @@
                     </a:lnL>
                     <a:lnR w="6350" cap="flat" cmpd="sng" algn="ctr">
                       <a:solidFill>
-                        <a:srgbClr val="000000"/>
+                        <a:srgbClr val="D9D9D9"/>
                       </a:solidFill>
                       <a:prstDash val="solid"/>
                       <a:round/>
@@ -4880,7 +4911,7 @@
                     </a:lnR>
                     <a:lnT w="6350" cap="flat" cmpd="sng" algn="ctr">
                       <a:solidFill>
-                        <a:srgbClr val="000000"/>
+                        <a:srgbClr val="D9D9D9"/>
                       </a:solidFill>
                       <a:prstDash val="solid"/>
                       <a:round/>
@@ -4889,7 +4920,7 @@
                     </a:lnT>
                     <a:lnB w="6350" cap="flat" cmpd="sng" algn="ctr">
                       <a:solidFill>
-                        <a:srgbClr val="000000"/>
+                        <a:srgbClr val="D9D9D9"/>
                       </a:solidFill>
                       <a:prstDash val="solid"/>
                       <a:round/>
@@ -4922,7 +4953,7 @@
                   <a:tcPr marL="9525" marR="9525" marT="9525" marB="0" anchor="b">
                     <a:lnL w="6350" cap="flat" cmpd="sng" algn="ctr">
                       <a:solidFill>
-                        <a:srgbClr val="000000"/>
+                        <a:srgbClr val="D9D9D9"/>
                       </a:solidFill>
                       <a:prstDash val="solid"/>
                       <a:round/>
@@ -4931,7 +4962,7 @@
                     </a:lnL>
                     <a:lnR w="6350" cap="flat" cmpd="sng" algn="ctr">
                       <a:solidFill>
-                        <a:srgbClr val="000000"/>
+                        <a:srgbClr val="D9D9D9"/>
                       </a:solidFill>
                       <a:prstDash val="solid"/>
                       <a:round/>
@@ -4940,7 +4971,7 @@
                     </a:lnR>
                     <a:lnT w="6350" cap="flat" cmpd="sng" algn="ctr">
                       <a:solidFill>
-                        <a:srgbClr val="000000"/>
+                        <a:srgbClr val="D9D9D9"/>
                       </a:solidFill>
                       <a:prstDash val="solid"/>
                       <a:round/>
@@ -4949,7 +4980,7 @@
                     </a:lnT>
                     <a:lnB w="6350" cap="flat" cmpd="sng" algn="ctr">
                       <a:solidFill>
-                        <a:srgbClr val="000000"/>
+                        <a:srgbClr val="D9D9D9"/>
                       </a:solidFill>
                       <a:prstDash val="solid"/>
                       <a:round/>
@@ -4968,9 +4999,9 @@
                         <a:buNone/>
                       </a:pPr>
                       <a:r>
-                        <a:rPr lang="he-IL" sz="1000" b="0" i="0" u="none" strike="noStrike">
+                        <a:rPr lang="he-IL" sz="1000" b="1" i="0" u="none" strike="noStrike">
                           <a:solidFill>
-                            <a:srgbClr val="000000"/>
+                            <a:srgbClr val="002F6C"/>
                           </a:solidFill>
                           <a:effectLst/>
                           <a:latin typeface="Arial" panose="020B0604020202020204" pitchFamily="34" charset="0"/>
@@ -4982,7 +5013,7 @@
                   <a:tcPr marL="9525" marR="9525" marT="9525" marB="0" anchor="b">
                     <a:lnL w="6350" cap="flat" cmpd="sng" algn="ctr">
                       <a:solidFill>
-                        <a:srgbClr val="000000"/>
+                        <a:srgbClr val="D9D9D9"/>
                       </a:solidFill>
                       <a:prstDash val="solid"/>
                       <a:round/>
@@ -4991,7 +5022,7 @@
                     </a:lnL>
                     <a:lnR w="6350" cap="flat" cmpd="sng" algn="ctr">
                       <a:solidFill>
-                        <a:srgbClr val="000000"/>
+                        <a:srgbClr val="D9D9D9"/>
                       </a:solidFill>
                       <a:prstDash val="solid"/>
                       <a:round/>
@@ -5000,7 +5031,7 @@
                     </a:lnR>
                     <a:lnT w="6350" cap="flat" cmpd="sng" algn="ctr">
                       <a:solidFill>
-                        <a:srgbClr val="000000"/>
+                        <a:srgbClr val="D9D9D9"/>
                       </a:solidFill>
                       <a:prstDash val="solid"/>
                       <a:round/>
@@ -5009,7 +5040,7 @@
                     </a:lnT>
                     <a:lnB w="6350" cap="flat" cmpd="sng" algn="ctr">
                       <a:solidFill>
-                        <a:srgbClr val="000000"/>
+                        <a:srgbClr val="D9D9D9"/>
                       </a:solidFill>
                       <a:prstDash val="solid"/>
                       <a:round/>
@@ -5049,7 +5080,7 @@
                   <a:tcPr marL="9525" marR="9525" marT="9525" marB="0" anchor="b">
                     <a:lnL w="6350" cap="flat" cmpd="sng" algn="ctr">
                       <a:solidFill>
-                        <a:srgbClr val="000000"/>
+                        <a:srgbClr val="D9D9D9"/>
                       </a:solidFill>
                       <a:prstDash val="solid"/>
                       <a:round/>
@@ -5058,7 +5089,7 @@
                     </a:lnL>
                     <a:lnR w="6350" cap="flat" cmpd="sng" algn="ctr">
                       <a:solidFill>
-                        <a:srgbClr val="000000"/>
+                        <a:srgbClr val="D9D9D9"/>
                       </a:solidFill>
                       <a:prstDash val="solid"/>
                       <a:round/>
@@ -5067,7 +5098,7 @@
                     </a:lnR>
                     <a:lnT w="6350" cap="flat" cmpd="sng" algn="ctr">
                       <a:solidFill>
-                        <a:srgbClr val="000000"/>
+                        <a:srgbClr val="D9D9D9"/>
                       </a:solidFill>
                       <a:prstDash val="solid"/>
                       <a:round/>
@@ -5076,7 +5107,7 @@
                     </a:lnT>
                     <a:lnB w="6350" cap="flat" cmpd="sng" algn="ctr">
                       <a:solidFill>
-                        <a:srgbClr val="000000"/>
+                        <a:srgbClr val="D9D9D9"/>
                       </a:solidFill>
                       <a:prstDash val="solid"/>
                       <a:round/>
@@ -5109,7 +5140,7 @@
                   <a:tcPr marL="9525" marR="9525" marT="9525" marB="0" anchor="b">
                     <a:lnL w="6350" cap="flat" cmpd="sng" algn="ctr">
                       <a:solidFill>
-                        <a:srgbClr val="000000"/>
+                        <a:srgbClr val="D9D9D9"/>
                       </a:solidFill>
                       <a:prstDash val="solid"/>
                       <a:round/>
@@ -5118,7 +5149,7 @@
                     </a:lnL>
                     <a:lnR w="6350" cap="flat" cmpd="sng" algn="ctr">
                       <a:solidFill>
-                        <a:srgbClr val="000000"/>
+                        <a:srgbClr val="D9D9D9"/>
                       </a:solidFill>
                       <a:prstDash val="solid"/>
                       <a:round/>
@@ -5127,7 +5158,7 @@
                     </a:lnR>
                     <a:lnT w="6350" cap="flat" cmpd="sng" algn="ctr">
                       <a:solidFill>
-                        <a:srgbClr val="000000"/>
+                        <a:srgbClr val="D9D9D9"/>
                       </a:solidFill>
                       <a:prstDash val="solid"/>
                       <a:round/>
@@ -5136,7 +5167,7 @@
                     </a:lnT>
                     <a:lnB w="6350" cap="flat" cmpd="sng" algn="ctr">
                       <a:solidFill>
-                        <a:srgbClr val="000000"/>
+                        <a:srgbClr val="D9D9D9"/>
                       </a:solidFill>
                       <a:prstDash val="solid"/>
                       <a:round/>
@@ -5169,7 +5200,7 @@
                   <a:tcPr marL="9525" marR="9525" marT="9525" marB="0" anchor="b">
                     <a:lnL w="6350" cap="flat" cmpd="sng" algn="ctr">
                       <a:solidFill>
-                        <a:srgbClr val="000000"/>
+                        <a:srgbClr val="D9D9D9"/>
                       </a:solidFill>
                       <a:prstDash val="solid"/>
                       <a:round/>
@@ -5178,7 +5209,7 @@
                     </a:lnL>
                     <a:lnR w="6350" cap="flat" cmpd="sng" algn="ctr">
                       <a:solidFill>
-                        <a:srgbClr val="000000"/>
+                        <a:srgbClr val="D9D9D9"/>
                       </a:solidFill>
                       <a:prstDash val="solid"/>
                       <a:round/>
@@ -5187,7 +5218,7 @@
                     </a:lnR>
                     <a:lnT w="6350" cap="flat" cmpd="sng" algn="ctr">
                       <a:solidFill>
-                        <a:srgbClr val="000000"/>
+                        <a:srgbClr val="D9D9D9"/>
                       </a:solidFill>
                       <a:prstDash val="solid"/>
                       <a:round/>
@@ -5196,7 +5227,7 @@
                     </a:lnT>
                     <a:lnB w="6350" cap="flat" cmpd="sng" algn="ctr">
                       <a:solidFill>
-                        <a:srgbClr val="000000"/>
+                        <a:srgbClr val="D9D9D9"/>
                       </a:solidFill>
                       <a:prstDash val="solid"/>
                       <a:round/>
@@ -5215,9 +5246,9 @@
                         <a:buNone/>
                       </a:pPr>
                       <a:r>
-                        <a:rPr lang="he-IL" sz="1000" b="0" i="0" u="none" strike="noStrike">
+                        <a:rPr lang="he-IL" sz="1000" b="1" i="0" u="none" strike="noStrike">
                           <a:solidFill>
-                            <a:srgbClr val="000000"/>
+                            <a:srgbClr val="002F6C"/>
                           </a:solidFill>
                           <a:effectLst/>
                           <a:latin typeface="Arial" panose="020B0604020202020204" pitchFamily="34" charset="0"/>
@@ -5229,7 +5260,7 @@
                   <a:tcPr marL="9525" marR="9525" marT="9525" marB="0" anchor="b">
                     <a:lnL w="6350" cap="flat" cmpd="sng" algn="ctr">
                       <a:solidFill>
-                        <a:srgbClr val="000000"/>
+                        <a:srgbClr val="D9D9D9"/>
                       </a:solidFill>
                       <a:prstDash val="solid"/>
                       <a:round/>
@@ -5238,7 +5269,7 @@
                     </a:lnL>
                     <a:lnR w="6350" cap="flat" cmpd="sng" algn="ctr">
                       <a:solidFill>
-                        <a:srgbClr val="000000"/>
+                        <a:srgbClr val="D9D9D9"/>
                       </a:solidFill>
                       <a:prstDash val="solid"/>
                       <a:round/>
@@ -5247,7 +5278,7 @@
                     </a:lnR>
                     <a:lnT w="6350" cap="flat" cmpd="sng" algn="ctr">
                       <a:solidFill>
-                        <a:srgbClr val="000000"/>
+                        <a:srgbClr val="D9D9D9"/>
                       </a:solidFill>
                       <a:prstDash val="solid"/>
                       <a:round/>
@@ -5256,7 +5287,7 @@
                     </a:lnT>
                     <a:lnB w="6350" cap="flat" cmpd="sng" algn="ctr">
                       <a:solidFill>
-                        <a:srgbClr val="000000"/>
+                        <a:srgbClr val="D9D9D9"/>
                       </a:solidFill>
                       <a:prstDash val="solid"/>
                       <a:round/>
@@ -5296,7 +5327,7 @@
                   <a:tcPr marL="9525" marR="9525" marT="9525" marB="0" anchor="b">
                     <a:lnL w="6350" cap="flat" cmpd="sng" algn="ctr">
                       <a:solidFill>
-                        <a:srgbClr val="000000"/>
+                        <a:srgbClr val="D9D9D9"/>
                       </a:solidFill>
                       <a:prstDash val="solid"/>
                       <a:round/>
@@ -5305,7 +5336,7 @@
                     </a:lnL>
                     <a:lnR w="6350" cap="flat" cmpd="sng" algn="ctr">
                       <a:solidFill>
-                        <a:srgbClr val="000000"/>
+                        <a:srgbClr val="D9D9D9"/>
                       </a:solidFill>
                       <a:prstDash val="solid"/>
                       <a:round/>
@@ -5314,7 +5345,7 @@
                     </a:lnR>
                     <a:lnT w="6350" cap="flat" cmpd="sng" algn="ctr">
                       <a:solidFill>
-                        <a:srgbClr val="000000"/>
+                        <a:srgbClr val="D9D9D9"/>
                       </a:solidFill>
                       <a:prstDash val="solid"/>
                       <a:round/>
@@ -5323,7 +5354,7 @@
                     </a:lnT>
                     <a:lnB w="6350" cap="flat" cmpd="sng" algn="ctr">
                       <a:solidFill>
-                        <a:srgbClr val="000000"/>
+                        <a:srgbClr val="D9D9D9"/>
                       </a:solidFill>
                       <a:prstDash val="solid"/>
                       <a:round/>
@@ -5356,7 +5387,7 @@
                   <a:tcPr marL="9525" marR="9525" marT="9525" marB="0" anchor="b">
                     <a:lnL w="6350" cap="flat" cmpd="sng" algn="ctr">
                       <a:solidFill>
-                        <a:srgbClr val="000000"/>
+                        <a:srgbClr val="D9D9D9"/>
                       </a:solidFill>
                       <a:prstDash val="solid"/>
                       <a:round/>
@@ -5365,7 +5396,7 @@
                     </a:lnL>
                     <a:lnR w="6350" cap="flat" cmpd="sng" algn="ctr">
                       <a:solidFill>
-                        <a:srgbClr val="000000"/>
+                        <a:srgbClr val="D9D9D9"/>
                       </a:solidFill>
                       <a:prstDash val="solid"/>
                       <a:round/>
@@ -5374,7 +5405,7 @@
                     </a:lnR>
                     <a:lnT w="6350" cap="flat" cmpd="sng" algn="ctr">
                       <a:solidFill>
-                        <a:srgbClr val="000000"/>
+                        <a:srgbClr val="D9D9D9"/>
                       </a:solidFill>
                       <a:prstDash val="solid"/>
                       <a:round/>
@@ -5383,7 +5414,7 @@
                     </a:lnT>
                     <a:lnB w="6350" cap="flat" cmpd="sng" algn="ctr">
                       <a:solidFill>
-                        <a:srgbClr val="000000"/>
+                        <a:srgbClr val="D9D9D9"/>
                       </a:solidFill>
                       <a:prstDash val="solid"/>
                       <a:round/>
@@ -5416,7 +5447,7 @@
                   <a:tcPr marL="9525" marR="9525" marT="9525" marB="0" anchor="b">
                     <a:lnL w="6350" cap="flat" cmpd="sng" algn="ctr">
                       <a:solidFill>
-                        <a:srgbClr val="000000"/>
+                        <a:srgbClr val="D9D9D9"/>
                       </a:solidFill>
                       <a:prstDash val="solid"/>
                       <a:round/>
@@ -5425,7 +5456,7 @@
                     </a:lnL>
                     <a:lnR w="6350" cap="flat" cmpd="sng" algn="ctr">
                       <a:solidFill>
-                        <a:srgbClr val="000000"/>
+                        <a:srgbClr val="D9D9D9"/>
                       </a:solidFill>
                       <a:prstDash val="solid"/>
                       <a:round/>
@@ -5434,7 +5465,7 @@
                     </a:lnR>
                     <a:lnT w="6350" cap="flat" cmpd="sng" algn="ctr">
                       <a:solidFill>
-                        <a:srgbClr val="000000"/>
+                        <a:srgbClr val="D9D9D9"/>
                       </a:solidFill>
                       <a:prstDash val="solid"/>
                       <a:round/>
@@ -5443,7 +5474,7 @@
                     </a:lnT>
                     <a:lnB w="6350" cap="flat" cmpd="sng" algn="ctr">
                       <a:solidFill>
-                        <a:srgbClr val="000000"/>
+                        <a:srgbClr val="D9D9D9"/>
                       </a:solidFill>
                       <a:prstDash val="solid"/>
                       <a:round/>
@@ -5462,9 +5493,9 @@
                         <a:buNone/>
                       </a:pPr>
                       <a:r>
-                        <a:rPr lang="he-IL" sz="1000" b="0" i="0" u="none" strike="noStrike">
+                        <a:rPr lang="he-IL" sz="1000" b="1" i="0" u="none" strike="noStrike">
                           <a:solidFill>
-                            <a:srgbClr val="000000"/>
+                            <a:srgbClr val="002F6C"/>
                           </a:solidFill>
                           <a:effectLst/>
                           <a:latin typeface="Arial" panose="020B0604020202020204" pitchFamily="34" charset="0"/>
@@ -5476,7 +5507,7 @@
                   <a:tcPr marL="9525" marR="9525" marT="9525" marB="0" anchor="b">
                     <a:lnL w="6350" cap="flat" cmpd="sng" algn="ctr">
                       <a:solidFill>
-                        <a:srgbClr val="000000"/>
+                        <a:srgbClr val="D9D9D9"/>
                       </a:solidFill>
                       <a:prstDash val="solid"/>
                       <a:round/>
@@ -5485,7 +5516,7 @@
                     </a:lnL>
                     <a:lnR w="6350" cap="flat" cmpd="sng" algn="ctr">
                       <a:solidFill>
-                        <a:srgbClr val="000000"/>
+                        <a:srgbClr val="D9D9D9"/>
                       </a:solidFill>
                       <a:prstDash val="solid"/>
                       <a:round/>
@@ -5494,7 +5525,7 @@
                     </a:lnR>
                     <a:lnT w="6350" cap="flat" cmpd="sng" algn="ctr">
                       <a:solidFill>
-                        <a:srgbClr val="000000"/>
+                        <a:srgbClr val="D9D9D9"/>
                       </a:solidFill>
                       <a:prstDash val="solid"/>
                       <a:round/>
@@ -5503,7 +5534,7 @@
                     </a:lnT>
                     <a:lnB w="6350" cap="flat" cmpd="sng" algn="ctr">
                       <a:solidFill>
-                        <a:srgbClr val="000000"/>
+                        <a:srgbClr val="D9D9D9"/>
                       </a:solidFill>
                       <a:prstDash val="solid"/>
                       <a:round/>
@@ -5543,7 +5574,7 @@
                   <a:tcPr marL="9525" marR="9525" marT="9525" marB="0" anchor="b">
                     <a:lnL w="6350" cap="flat" cmpd="sng" algn="ctr">
                       <a:solidFill>
-                        <a:srgbClr val="000000"/>
+                        <a:srgbClr val="D9D9D9"/>
                       </a:solidFill>
                       <a:prstDash val="solid"/>
                       <a:round/>
@@ -5552,7 +5583,7 @@
                     </a:lnL>
                     <a:lnR w="6350" cap="flat" cmpd="sng" algn="ctr">
                       <a:solidFill>
-                        <a:srgbClr val="000000"/>
+                        <a:srgbClr val="D9D9D9"/>
                       </a:solidFill>
                       <a:prstDash val="solid"/>
                       <a:round/>
@@ -5561,7 +5592,7 @@
                     </a:lnR>
                     <a:lnT w="6350" cap="flat" cmpd="sng" algn="ctr">
                       <a:solidFill>
-                        <a:srgbClr val="000000"/>
+                        <a:srgbClr val="D9D9D9"/>
                       </a:solidFill>
                       <a:prstDash val="solid"/>
                       <a:round/>
@@ -5570,7 +5601,7 @@
                     </a:lnT>
                     <a:lnB w="6350" cap="flat" cmpd="sng" algn="ctr">
                       <a:solidFill>
-                        <a:srgbClr val="000000"/>
+                        <a:srgbClr val="D9D9D9"/>
                       </a:solidFill>
                       <a:prstDash val="solid"/>
                       <a:round/>
@@ -5603,7 +5634,7 @@
                   <a:tcPr marL="9525" marR="9525" marT="9525" marB="0" anchor="b">
                     <a:lnL w="6350" cap="flat" cmpd="sng" algn="ctr">
                       <a:solidFill>
-                        <a:srgbClr val="000000"/>
+                        <a:srgbClr val="D9D9D9"/>
                       </a:solidFill>
                       <a:prstDash val="solid"/>
                       <a:round/>
@@ -5612,7 +5643,7 @@
                     </a:lnL>
                     <a:lnR w="6350" cap="flat" cmpd="sng" algn="ctr">
                       <a:solidFill>
-                        <a:srgbClr val="000000"/>
+                        <a:srgbClr val="D9D9D9"/>
                       </a:solidFill>
                       <a:prstDash val="solid"/>
                       <a:round/>
@@ -5621,7 +5652,7 @@
                     </a:lnR>
                     <a:lnT w="6350" cap="flat" cmpd="sng" algn="ctr">
                       <a:solidFill>
-                        <a:srgbClr val="000000"/>
+                        <a:srgbClr val="D9D9D9"/>
                       </a:solidFill>
                       <a:prstDash val="solid"/>
                       <a:round/>
@@ -5630,7 +5661,7 @@
                     </a:lnT>
                     <a:lnB w="6350" cap="flat" cmpd="sng" algn="ctr">
                       <a:solidFill>
-                        <a:srgbClr val="000000"/>
+                        <a:srgbClr val="D9D9D9"/>
                       </a:solidFill>
                       <a:prstDash val="solid"/>
                       <a:round/>
@@ -5663,7 +5694,7 @@
                   <a:tcPr marL="9525" marR="9525" marT="9525" marB="0" anchor="b">
                     <a:lnL w="6350" cap="flat" cmpd="sng" algn="ctr">
                       <a:solidFill>
-                        <a:srgbClr val="000000"/>
+                        <a:srgbClr val="D9D9D9"/>
                       </a:solidFill>
                       <a:prstDash val="solid"/>
                       <a:round/>
@@ -5672,7 +5703,7 @@
                     </a:lnL>
                     <a:lnR w="6350" cap="flat" cmpd="sng" algn="ctr">
                       <a:solidFill>
-                        <a:srgbClr val="000000"/>
+                        <a:srgbClr val="D9D9D9"/>
                       </a:solidFill>
                       <a:prstDash val="solid"/>
                       <a:round/>
@@ -5681,7 +5712,7 @@
                     </a:lnR>
                     <a:lnT w="6350" cap="flat" cmpd="sng" algn="ctr">
                       <a:solidFill>
-                        <a:srgbClr val="000000"/>
+                        <a:srgbClr val="D9D9D9"/>
                       </a:solidFill>
                       <a:prstDash val="solid"/>
                       <a:round/>
@@ -5690,7 +5721,7 @@
                     </a:lnT>
                     <a:lnB w="6350" cap="flat" cmpd="sng" algn="ctr">
                       <a:solidFill>
-                        <a:srgbClr val="000000"/>
+                        <a:srgbClr val="D9D9D9"/>
                       </a:solidFill>
                       <a:prstDash val="solid"/>
                       <a:round/>
@@ -5709,9 +5740,9 @@
                         <a:buNone/>
                       </a:pPr>
                       <a:r>
-                        <a:rPr lang="he-IL" sz="1000" b="0" i="0" u="none" strike="noStrike" dirty="0">
+                        <a:rPr lang="he-IL" sz="1000" b="1" i="0" u="none" strike="noStrike" dirty="0">
                           <a:solidFill>
-                            <a:srgbClr val="000000"/>
+                            <a:srgbClr val="002F6C"/>
                           </a:solidFill>
                           <a:effectLst/>
                           <a:latin typeface="Arial" panose="020B0604020202020204" pitchFamily="34" charset="0"/>
@@ -5723,7 +5754,7 @@
                   <a:tcPr marL="9525" marR="9525" marT="9525" marB="0" anchor="b">
                     <a:lnL w="6350" cap="flat" cmpd="sng" algn="ctr">
                       <a:solidFill>
-                        <a:srgbClr val="000000"/>
+                        <a:srgbClr val="D9D9D9"/>
                       </a:solidFill>
                       <a:prstDash val="solid"/>
                       <a:round/>
@@ -5732,7 +5763,7 @@
                     </a:lnL>
                     <a:lnR w="6350" cap="flat" cmpd="sng" algn="ctr">
                       <a:solidFill>
-                        <a:srgbClr val="000000"/>
+                        <a:srgbClr val="D9D9D9"/>
                       </a:solidFill>
                       <a:prstDash val="solid"/>
                       <a:round/>
@@ -5741,7 +5772,7 @@
                     </a:lnR>
                     <a:lnT w="6350" cap="flat" cmpd="sng" algn="ctr">
                       <a:solidFill>
-                        <a:srgbClr val="000000"/>
+                        <a:srgbClr val="D9D9D9"/>
                       </a:solidFill>
                       <a:prstDash val="solid"/>
                       <a:round/>
@@ -5750,7 +5781,7 @@
                     </a:lnT>
                     <a:lnB w="6350" cap="flat" cmpd="sng" algn="ctr">
                       <a:solidFill>
-                        <a:srgbClr val="000000"/>
+                        <a:srgbClr val="D9D9D9"/>
                       </a:solidFill>
                       <a:prstDash val="solid"/>
                       <a:round/>
@@ -5790,7 +5821,7 @@
                   <a:tcPr marL="9525" marR="9525" marT="9525" marB="0" anchor="b">
                     <a:lnL w="6350" cap="flat" cmpd="sng" algn="ctr">
                       <a:solidFill>
-                        <a:srgbClr val="000000"/>
+                        <a:srgbClr val="D9D9D9"/>
                       </a:solidFill>
                       <a:prstDash val="solid"/>
                       <a:round/>
@@ -5799,7 +5830,7 @@
                     </a:lnL>
                     <a:lnR w="6350" cap="flat" cmpd="sng" algn="ctr">
                       <a:solidFill>
-                        <a:srgbClr val="000000"/>
+                        <a:srgbClr val="D9D9D9"/>
                       </a:solidFill>
                       <a:prstDash val="solid"/>
                       <a:round/>
@@ -5808,7 +5839,7 @@
                     </a:lnR>
                     <a:lnT w="6350" cap="flat" cmpd="sng" algn="ctr">
                       <a:solidFill>
-                        <a:srgbClr val="000000"/>
+                        <a:srgbClr val="D9D9D9"/>
                       </a:solidFill>
                       <a:prstDash val="solid"/>
                       <a:round/>
@@ -5817,7 +5848,7 @@
                     </a:lnT>
                     <a:lnB w="6350" cap="flat" cmpd="sng" algn="ctr">
                       <a:solidFill>
-                        <a:srgbClr val="000000"/>
+                        <a:srgbClr val="D9D9D9"/>
                       </a:solidFill>
                       <a:prstDash val="solid"/>
                       <a:round/>
@@ -5850,7 +5881,7 @@
                   <a:tcPr marL="9525" marR="9525" marT="9525" marB="0" anchor="b">
                     <a:lnL w="6350" cap="flat" cmpd="sng" algn="ctr">
                       <a:solidFill>
-                        <a:srgbClr val="000000"/>
+                        <a:srgbClr val="D9D9D9"/>
                       </a:solidFill>
                       <a:prstDash val="solid"/>
                       <a:round/>
@@ -5859,7 +5890,7 @@
                     </a:lnL>
                     <a:lnR w="6350" cap="flat" cmpd="sng" algn="ctr">
                       <a:solidFill>
-                        <a:srgbClr val="000000"/>
+                        <a:srgbClr val="D9D9D9"/>
                       </a:solidFill>
                       <a:prstDash val="solid"/>
                       <a:round/>
@@ -5868,7 +5899,7 @@
                     </a:lnR>
                     <a:lnT w="6350" cap="flat" cmpd="sng" algn="ctr">
                       <a:solidFill>
-                        <a:srgbClr val="000000"/>
+                        <a:srgbClr val="D9D9D9"/>
                       </a:solidFill>
                       <a:prstDash val="solid"/>
                       <a:round/>
@@ -5877,7 +5908,7 @@
                     </a:lnT>
                     <a:lnB w="6350" cap="flat" cmpd="sng" algn="ctr">
                       <a:solidFill>
-                        <a:srgbClr val="000000"/>
+                        <a:srgbClr val="D9D9D9"/>
                       </a:solidFill>
                       <a:prstDash val="solid"/>
                       <a:round/>
@@ -5910,7 +5941,7 @@
                   <a:tcPr marL="9525" marR="9525" marT="9525" marB="0" anchor="b">
                     <a:lnL w="6350" cap="flat" cmpd="sng" algn="ctr">
                       <a:solidFill>
-                        <a:srgbClr val="000000"/>
+                        <a:srgbClr val="D9D9D9"/>
                       </a:solidFill>
                       <a:prstDash val="solid"/>
                       <a:round/>
@@ -5919,7 +5950,7 @@
                     </a:lnL>
                     <a:lnR w="6350" cap="flat" cmpd="sng" algn="ctr">
                       <a:solidFill>
-                        <a:srgbClr val="000000"/>
+                        <a:srgbClr val="D9D9D9"/>
                       </a:solidFill>
                       <a:prstDash val="solid"/>
                       <a:round/>
@@ -5928,7 +5959,7 @@
                     </a:lnR>
                     <a:lnT w="6350" cap="flat" cmpd="sng" algn="ctr">
                       <a:solidFill>
-                        <a:srgbClr val="000000"/>
+                        <a:srgbClr val="D9D9D9"/>
                       </a:solidFill>
                       <a:prstDash val="solid"/>
                       <a:round/>
@@ -5937,7 +5968,7 @@
                     </a:lnT>
                     <a:lnB w="6350" cap="flat" cmpd="sng" algn="ctr">
                       <a:solidFill>
-                        <a:srgbClr val="000000"/>
+                        <a:srgbClr val="D9D9D9"/>
                       </a:solidFill>
                       <a:prstDash val="solid"/>
                       <a:round/>
@@ -5956,9 +5987,9 @@
                         <a:buNone/>
                       </a:pPr>
                       <a:r>
-                        <a:rPr lang="he-IL" sz="1000" b="0" i="0" u="none" strike="noStrike" dirty="0">
+                        <a:rPr lang="he-IL" sz="1000" b="1" i="0" u="none" strike="noStrike" dirty="0">
                           <a:solidFill>
-                            <a:srgbClr val="000000"/>
+                            <a:srgbClr val="E0A62B"/>
                           </a:solidFill>
                           <a:effectLst/>
                           <a:latin typeface="Arial" panose="020B0604020202020204" pitchFamily="34" charset="0"/>
@@ -5970,7 +6001,7 @@
                   <a:tcPr marL="9525" marR="9525" marT="9525" marB="0" anchor="b">
                     <a:lnL w="6350" cap="flat" cmpd="sng" algn="ctr">
                       <a:solidFill>
-                        <a:srgbClr val="000000"/>
+                        <a:srgbClr val="D9D9D9"/>
                       </a:solidFill>
                       <a:prstDash val="solid"/>
                       <a:round/>
@@ -5979,7 +6010,7 @@
                     </a:lnL>
                     <a:lnR w="6350" cap="flat" cmpd="sng" algn="ctr">
                       <a:solidFill>
-                        <a:srgbClr val="000000"/>
+                        <a:srgbClr val="D9D9D9"/>
                       </a:solidFill>
                       <a:prstDash val="solid"/>
                       <a:round/>
@@ -5988,7 +6019,7 @@
                     </a:lnR>
                     <a:lnT w="6350" cap="flat" cmpd="sng" algn="ctr">
                       <a:solidFill>
-                        <a:srgbClr val="000000"/>
+                        <a:srgbClr val="D9D9D9"/>
                       </a:solidFill>
                       <a:prstDash val="solid"/>
                       <a:round/>
@@ -5997,7 +6028,7 @@
                     </a:lnT>
                     <a:lnB w="6350" cap="flat" cmpd="sng" algn="ctr">
                       <a:solidFill>
-                        <a:srgbClr val="000000"/>
+                        <a:srgbClr val="D9D9D9"/>
                       </a:solidFill>
                       <a:prstDash val="solid"/>
                       <a:round/>
@@ -6037,7 +6068,7 @@
                   <a:tcPr marL="9525" marR="9525" marT="9525" marB="0" anchor="b">
                     <a:lnL w="6350" cap="flat" cmpd="sng" algn="ctr">
                       <a:solidFill>
-                        <a:srgbClr val="000000"/>
+                        <a:srgbClr val="D9D9D9"/>
                       </a:solidFill>
                       <a:prstDash val="solid"/>
                       <a:round/>
@@ -6046,7 +6077,7 @@
                     </a:lnL>
                     <a:lnR w="6350" cap="flat" cmpd="sng" algn="ctr">
                       <a:solidFill>
-                        <a:srgbClr val="000000"/>
+                        <a:srgbClr val="D9D9D9"/>
                       </a:solidFill>
                       <a:prstDash val="solid"/>
                       <a:round/>
@@ -6055,7 +6086,7 @@
                     </a:lnR>
                     <a:lnT w="6350" cap="flat" cmpd="sng" algn="ctr">
                       <a:solidFill>
-                        <a:srgbClr val="000000"/>
+                        <a:srgbClr val="D9D9D9"/>
                       </a:solidFill>
                       <a:prstDash val="solid"/>
                       <a:round/>
@@ -6064,7 +6095,7 @@
                     </a:lnT>
                     <a:lnB w="6350" cap="flat" cmpd="sng" algn="ctr">
                       <a:solidFill>
-                        <a:srgbClr val="000000"/>
+                        <a:srgbClr val="D9D9D9"/>
                       </a:solidFill>
                       <a:prstDash val="solid"/>
                       <a:round/>
@@ -6097,7 +6128,7 @@
                   <a:tcPr marL="9525" marR="9525" marT="9525" marB="0" anchor="b">
                     <a:lnL w="6350" cap="flat" cmpd="sng" algn="ctr">
                       <a:solidFill>
-                        <a:srgbClr val="000000"/>
+                        <a:srgbClr val="D9D9D9"/>
                       </a:solidFill>
                       <a:prstDash val="solid"/>
                       <a:round/>
@@ -6106,7 +6137,7 @@
                     </a:lnL>
                     <a:lnR w="6350" cap="flat" cmpd="sng" algn="ctr">
                       <a:solidFill>
-                        <a:srgbClr val="000000"/>
+                        <a:srgbClr val="D9D9D9"/>
                       </a:solidFill>
                       <a:prstDash val="solid"/>
                       <a:round/>
@@ -6115,7 +6146,7 @@
                     </a:lnR>
                     <a:lnT w="6350" cap="flat" cmpd="sng" algn="ctr">
                       <a:solidFill>
-                        <a:srgbClr val="000000"/>
+                        <a:srgbClr val="D9D9D9"/>
                       </a:solidFill>
                       <a:prstDash val="solid"/>
                       <a:round/>
@@ -6124,7 +6155,7 @@
                     </a:lnT>
                     <a:lnB w="6350" cap="flat" cmpd="sng" algn="ctr">
                       <a:solidFill>
-                        <a:srgbClr val="000000"/>
+                        <a:srgbClr val="D9D9D9"/>
                       </a:solidFill>
                       <a:prstDash val="solid"/>
                       <a:round/>
@@ -6157,7 +6188,7 @@
                   <a:tcPr marL="9525" marR="9525" marT="9525" marB="0" anchor="b">
                     <a:lnL w="6350" cap="flat" cmpd="sng" algn="ctr">
                       <a:solidFill>
-                        <a:srgbClr val="000000"/>
+                        <a:srgbClr val="D9D9D9"/>
                       </a:solidFill>
                       <a:prstDash val="solid"/>
                       <a:round/>
@@ -6166,7 +6197,7 @@
                     </a:lnL>
                     <a:lnR w="6350" cap="flat" cmpd="sng" algn="ctr">
                       <a:solidFill>
-                        <a:srgbClr val="000000"/>
+                        <a:srgbClr val="D9D9D9"/>
                       </a:solidFill>
                       <a:prstDash val="solid"/>
                       <a:round/>
@@ -6175,7 +6206,7 @@
                     </a:lnR>
                     <a:lnT w="6350" cap="flat" cmpd="sng" algn="ctr">
                       <a:solidFill>
-                        <a:srgbClr val="000000"/>
+                        <a:srgbClr val="D9D9D9"/>
                       </a:solidFill>
                       <a:prstDash val="solid"/>
                       <a:round/>
@@ -6184,7 +6215,7 @@
                     </a:lnT>
                     <a:lnB w="6350" cap="flat" cmpd="sng" algn="ctr">
                       <a:solidFill>
-                        <a:srgbClr val="000000"/>
+                        <a:srgbClr val="D9D9D9"/>
                       </a:solidFill>
                       <a:prstDash val="solid"/>
                       <a:round/>
@@ -6203,9 +6234,9 @@
                         <a:buNone/>
                       </a:pPr>
                       <a:r>
-                        <a:rPr lang="he-IL" sz="1000" b="0" i="0" u="none" strike="noStrike">
+                        <a:rPr lang="he-IL" sz="1000" b="1" i="0" u="none" strike="noStrike">
                           <a:solidFill>
-                            <a:srgbClr val="000000"/>
+                            <a:srgbClr val="E0A62B"/>
                           </a:solidFill>
                           <a:effectLst/>
                           <a:latin typeface="Arial" panose="020B0604020202020204" pitchFamily="34" charset="0"/>
@@ -6217,7 +6248,7 @@
                   <a:tcPr marL="9525" marR="9525" marT="9525" marB="0" anchor="b">
                     <a:lnL w="6350" cap="flat" cmpd="sng" algn="ctr">
                       <a:solidFill>
-                        <a:srgbClr val="000000"/>
+                        <a:srgbClr val="D9D9D9"/>
                       </a:solidFill>
                       <a:prstDash val="solid"/>
                       <a:round/>
@@ -6226,7 +6257,7 @@
                     </a:lnL>
                     <a:lnR w="6350" cap="flat" cmpd="sng" algn="ctr">
                       <a:solidFill>
-                        <a:srgbClr val="000000"/>
+                        <a:srgbClr val="D9D9D9"/>
                       </a:solidFill>
                       <a:prstDash val="solid"/>
                       <a:round/>
@@ -6235,7 +6266,7 @@
                     </a:lnR>
                     <a:lnT w="6350" cap="flat" cmpd="sng" algn="ctr">
                       <a:solidFill>
-                        <a:srgbClr val="000000"/>
+                        <a:srgbClr val="D9D9D9"/>
                       </a:solidFill>
                       <a:prstDash val="solid"/>
                       <a:round/>
@@ -6244,7 +6275,7 @@
                     </a:lnT>
                     <a:lnB w="6350" cap="flat" cmpd="sng" algn="ctr">
                       <a:solidFill>
-                        <a:srgbClr val="000000"/>
+                        <a:srgbClr val="D9D9D9"/>
                       </a:solidFill>
                       <a:prstDash val="solid"/>
                       <a:round/>
@@ -6284,7 +6315,7 @@
                   <a:tcPr marL="9525" marR="9525" marT="9525" marB="0" anchor="b">
                     <a:lnL w="6350" cap="flat" cmpd="sng" algn="ctr">
                       <a:solidFill>
-                        <a:srgbClr val="000000"/>
+                        <a:srgbClr val="D9D9D9"/>
                       </a:solidFill>
                       <a:prstDash val="solid"/>
                       <a:round/>
@@ -6293,7 +6324,7 @@
                     </a:lnL>
                     <a:lnR w="6350" cap="flat" cmpd="sng" algn="ctr">
                       <a:solidFill>
-                        <a:srgbClr val="000000"/>
+                        <a:srgbClr val="D9D9D9"/>
                       </a:solidFill>
                       <a:prstDash val="solid"/>
                       <a:round/>
@@ -6302,7 +6333,7 @@
                     </a:lnR>
                     <a:lnT w="6350" cap="flat" cmpd="sng" algn="ctr">
                       <a:solidFill>
-                        <a:srgbClr val="000000"/>
+                        <a:srgbClr val="D9D9D9"/>
                       </a:solidFill>
                       <a:prstDash val="solid"/>
                       <a:round/>
@@ -6311,7 +6342,7 @@
                     </a:lnT>
                     <a:lnB w="6350" cap="flat" cmpd="sng" algn="ctr">
                       <a:solidFill>
-                        <a:srgbClr val="000000"/>
+                        <a:srgbClr val="D9D9D9"/>
                       </a:solidFill>
                       <a:prstDash val="solid"/>
                       <a:round/>
@@ -6344,7 +6375,7 @@
                   <a:tcPr marL="9525" marR="9525" marT="9525" marB="0" anchor="b">
                     <a:lnL w="6350" cap="flat" cmpd="sng" algn="ctr">
                       <a:solidFill>
-                        <a:srgbClr val="000000"/>
+                        <a:srgbClr val="D9D9D9"/>
                       </a:solidFill>
                       <a:prstDash val="solid"/>
                       <a:round/>
@@ -6353,7 +6384,7 @@
                     </a:lnL>
                     <a:lnR w="6350" cap="flat" cmpd="sng" algn="ctr">
                       <a:solidFill>
-                        <a:srgbClr val="000000"/>
+                        <a:srgbClr val="D9D9D9"/>
                       </a:solidFill>
                       <a:prstDash val="solid"/>
                       <a:round/>
@@ -6362,7 +6393,7 @@
                     </a:lnR>
                     <a:lnT w="6350" cap="flat" cmpd="sng" algn="ctr">
                       <a:solidFill>
-                        <a:srgbClr val="000000"/>
+                        <a:srgbClr val="D9D9D9"/>
                       </a:solidFill>
                       <a:prstDash val="solid"/>
                       <a:round/>
@@ -6371,7 +6402,7 @@
                     </a:lnT>
                     <a:lnB w="6350" cap="flat" cmpd="sng" algn="ctr">
                       <a:solidFill>
-                        <a:srgbClr val="000000"/>
+                        <a:srgbClr val="D9D9D9"/>
                       </a:solidFill>
                       <a:prstDash val="solid"/>
                       <a:round/>
@@ -6404,7 +6435,7 @@
                   <a:tcPr marL="9525" marR="9525" marT="9525" marB="0" anchor="b">
                     <a:lnL w="6350" cap="flat" cmpd="sng" algn="ctr">
                       <a:solidFill>
-                        <a:srgbClr val="000000"/>
+                        <a:srgbClr val="D9D9D9"/>
                       </a:solidFill>
                       <a:prstDash val="solid"/>
                       <a:round/>
@@ -6413,7 +6444,7 @@
                     </a:lnL>
                     <a:lnR w="6350" cap="flat" cmpd="sng" algn="ctr">
                       <a:solidFill>
-                        <a:srgbClr val="000000"/>
+                        <a:srgbClr val="D9D9D9"/>
                       </a:solidFill>
                       <a:prstDash val="solid"/>
                       <a:round/>
@@ -6422,7 +6453,7 @@
                     </a:lnR>
                     <a:lnT w="6350" cap="flat" cmpd="sng" algn="ctr">
                       <a:solidFill>
-                        <a:srgbClr val="000000"/>
+                        <a:srgbClr val="D9D9D9"/>
                       </a:solidFill>
                       <a:prstDash val="solid"/>
                       <a:round/>
@@ -6431,7 +6462,7 @@
                     </a:lnT>
                     <a:lnB w="6350" cap="flat" cmpd="sng" algn="ctr">
                       <a:solidFill>
-                        <a:srgbClr val="000000"/>
+                        <a:srgbClr val="D9D9D9"/>
                       </a:solidFill>
                       <a:prstDash val="solid"/>
                       <a:round/>
@@ -6450,9 +6481,9 @@
                         <a:buNone/>
                       </a:pPr>
                       <a:r>
-                        <a:rPr lang="he-IL" sz="1000" b="0" i="0" u="none" strike="noStrike" dirty="0">
+                        <a:rPr lang="he-IL" sz="1000" b="1" i="0" u="none" strike="noStrike" dirty="0">
                           <a:solidFill>
-                            <a:srgbClr val="000000"/>
+                            <a:srgbClr val="E0A62B"/>
                           </a:solidFill>
                           <a:effectLst/>
                           <a:latin typeface="Arial" panose="020B0604020202020204" pitchFamily="34" charset="0"/>
@@ -6464,7 +6495,7 @@
                   <a:tcPr marL="9525" marR="9525" marT="9525" marB="0" anchor="b">
                     <a:lnL w="6350" cap="flat" cmpd="sng" algn="ctr">
                       <a:solidFill>
-                        <a:srgbClr val="000000"/>
+                        <a:srgbClr val="D9D9D9"/>
                       </a:solidFill>
                       <a:prstDash val="solid"/>
                       <a:round/>
@@ -6473,7 +6504,7 @@
                     </a:lnL>
                     <a:lnR w="6350" cap="flat" cmpd="sng" algn="ctr">
                       <a:solidFill>
-                        <a:srgbClr val="000000"/>
+                        <a:srgbClr val="D9D9D9"/>
                       </a:solidFill>
                       <a:prstDash val="solid"/>
                       <a:round/>
@@ -6482,7 +6513,7 @@
                     </a:lnR>
                     <a:lnT w="6350" cap="flat" cmpd="sng" algn="ctr">
                       <a:solidFill>
-                        <a:srgbClr val="000000"/>
+                        <a:srgbClr val="D9D9D9"/>
                       </a:solidFill>
                       <a:prstDash val="solid"/>
                       <a:round/>
@@ -6491,7 +6522,7 @@
                     </a:lnT>
                     <a:lnB w="6350" cap="flat" cmpd="sng" algn="ctr">
                       <a:solidFill>
-                        <a:srgbClr val="000000"/>
+                        <a:srgbClr val="D9D9D9"/>
                       </a:solidFill>
                       <a:prstDash val="solid"/>
                       <a:round/>
@@ -6531,7 +6562,7 @@
                   <a:tcPr marL="9525" marR="9525" marT="9525" marB="0" anchor="b">
                     <a:lnL w="6350" cap="flat" cmpd="sng" algn="ctr">
                       <a:solidFill>
-                        <a:srgbClr val="000000"/>
+                        <a:srgbClr val="D9D9D9"/>
                       </a:solidFill>
                       <a:prstDash val="solid"/>
                       <a:round/>
@@ -6540,7 +6571,7 @@
                     </a:lnL>
                     <a:lnR w="6350" cap="flat" cmpd="sng" algn="ctr">
                       <a:solidFill>
-                        <a:srgbClr val="000000"/>
+                        <a:srgbClr val="D9D9D9"/>
                       </a:solidFill>
                       <a:prstDash val="solid"/>
                       <a:round/>
@@ -6549,7 +6580,7 @@
                     </a:lnR>
                     <a:lnT w="6350" cap="flat" cmpd="sng" algn="ctr">
                       <a:solidFill>
-                        <a:srgbClr val="000000"/>
+                        <a:srgbClr val="D9D9D9"/>
                       </a:solidFill>
                       <a:prstDash val="solid"/>
                       <a:round/>
@@ -6558,7 +6589,7 @@
                     </a:lnT>
                     <a:lnB w="6350" cap="flat" cmpd="sng" algn="ctr">
                       <a:solidFill>
-                        <a:srgbClr val="000000"/>
+                        <a:srgbClr val="D9D9D9"/>
                       </a:solidFill>
                       <a:prstDash val="solid"/>
                       <a:round/>
@@ -6591,7 +6622,7 @@
                   <a:tcPr marL="9525" marR="9525" marT="9525" marB="0" anchor="b">
                     <a:lnL w="6350" cap="flat" cmpd="sng" algn="ctr">
                       <a:solidFill>
-                        <a:srgbClr val="000000"/>
+                        <a:srgbClr val="D9D9D9"/>
                       </a:solidFill>
                       <a:prstDash val="solid"/>
                       <a:round/>
@@ -6600,7 +6631,7 @@
                     </a:lnL>
                     <a:lnR w="6350" cap="flat" cmpd="sng" algn="ctr">
                       <a:solidFill>
-                        <a:srgbClr val="000000"/>
+                        <a:srgbClr val="D9D9D9"/>
                       </a:solidFill>
                       <a:prstDash val="solid"/>
                       <a:round/>
@@ -6609,7 +6640,7 @@
                     </a:lnR>
                     <a:lnT w="6350" cap="flat" cmpd="sng" algn="ctr">
                       <a:solidFill>
-                        <a:srgbClr val="000000"/>
+                        <a:srgbClr val="D9D9D9"/>
                       </a:solidFill>
                       <a:prstDash val="solid"/>
                       <a:round/>
@@ -6618,7 +6649,7 @@
                     </a:lnT>
                     <a:lnB w="6350" cap="flat" cmpd="sng" algn="ctr">
                       <a:solidFill>
-                        <a:srgbClr val="000000"/>
+                        <a:srgbClr val="D9D9D9"/>
                       </a:solidFill>
                       <a:prstDash val="solid"/>
                       <a:round/>
@@ -6651,7 +6682,7 @@
                   <a:tcPr marL="9525" marR="9525" marT="9525" marB="0" anchor="b">
                     <a:lnL w="6350" cap="flat" cmpd="sng" algn="ctr">
                       <a:solidFill>
-                        <a:srgbClr val="000000"/>
+                        <a:srgbClr val="D9D9D9"/>
                       </a:solidFill>
                       <a:prstDash val="solid"/>
                       <a:round/>
@@ -6660,7 +6691,7 @@
                     </a:lnL>
                     <a:lnR w="6350" cap="flat" cmpd="sng" algn="ctr">
                       <a:solidFill>
-                        <a:srgbClr val="000000"/>
+                        <a:srgbClr val="D9D9D9"/>
                       </a:solidFill>
                       <a:prstDash val="solid"/>
                       <a:round/>
@@ -6669,7 +6700,7 @@
                     </a:lnR>
                     <a:lnT w="6350" cap="flat" cmpd="sng" algn="ctr">
                       <a:solidFill>
-                        <a:srgbClr val="000000"/>
+                        <a:srgbClr val="D9D9D9"/>
                       </a:solidFill>
                       <a:prstDash val="solid"/>
                       <a:round/>
@@ -6678,7 +6709,7 @@
                     </a:lnT>
                     <a:lnB w="6350" cap="flat" cmpd="sng" algn="ctr">
                       <a:solidFill>
-                        <a:srgbClr val="000000"/>
+                        <a:srgbClr val="D9D9D9"/>
                       </a:solidFill>
                       <a:prstDash val="solid"/>
                       <a:round/>
@@ -6697,9 +6728,9 @@
                         <a:buNone/>
                       </a:pPr>
                       <a:r>
-                        <a:rPr lang="he-IL" sz="1000" b="0" i="0" u="none" strike="noStrike" dirty="0">
+                        <a:rPr lang="he-IL" sz="1000" b="1" i="0" u="none" strike="noStrike" dirty="0">
                           <a:solidFill>
-                            <a:srgbClr val="000000"/>
+                            <a:srgbClr val="E0A62B"/>
                           </a:solidFill>
                           <a:effectLst/>
                           <a:latin typeface="Arial" panose="020B0604020202020204" pitchFamily="34" charset="0"/>
@@ -6711,7 +6742,7 @@
                   <a:tcPr marL="9525" marR="9525" marT="9525" marB="0" anchor="b">
                     <a:lnL w="6350" cap="flat" cmpd="sng" algn="ctr">
                       <a:solidFill>
-                        <a:srgbClr val="000000"/>
+                        <a:srgbClr val="D9D9D9"/>
                       </a:solidFill>
                       <a:prstDash val="solid"/>
                       <a:round/>
@@ -6720,7 +6751,7 @@
                     </a:lnL>
                     <a:lnR w="6350" cap="flat" cmpd="sng" algn="ctr">
                       <a:solidFill>
-                        <a:srgbClr val="000000"/>
+                        <a:srgbClr val="D9D9D9"/>
                       </a:solidFill>
                       <a:prstDash val="solid"/>
                       <a:round/>
@@ -6729,7 +6760,7 @@
                     </a:lnR>
                     <a:lnT w="6350" cap="flat" cmpd="sng" algn="ctr">
                       <a:solidFill>
-                        <a:srgbClr val="000000"/>
+                        <a:srgbClr val="D9D9D9"/>
                       </a:solidFill>
                       <a:prstDash val="solid"/>
                       <a:round/>
@@ -6738,7 +6769,7 @@
                     </a:lnT>
                     <a:lnB w="6350" cap="flat" cmpd="sng" algn="ctr">
                       <a:solidFill>
-                        <a:srgbClr val="000000"/>
+                        <a:srgbClr val="D9D9D9"/>
                       </a:solidFill>
                       <a:prstDash val="solid"/>
                       <a:round/>
@@ -6778,7 +6809,7 @@
                   <a:tcPr marL="9525" marR="9525" marT="9525" marB="0" anchor="b">
                     <a:lnL w="6350" cap="flat" cmpd="sng" algn="ctr">
                       <a:solidFill>
-                        <a:srgbClr val="000000"/>
+                        <a:srgbClr val="D9D9D9"/>
                       </a:solidFill>
                       <a:prstDash val="solid"/>
                       <a:round/>
@@ -6787,7 +6818,7 @@
                     </a:lnL>
                     <a:lnR w="6350" cap="flat" cmpd="sng" algn="ctr">
                       <a:solidFill>
-                        <a:srgbClr val="000000"/>
+                        <a:srgbClr val="D9D9D9"/>
                       </a:solidFill>
                       <a:prstDash val="solid"/>
                       <a:round/>
@@ -6796,7 +6827,7 @@
                     </a:lnR>
                     <a:lnT w="6350" cap="flat" cmpd="sng" algn="ctr">
                       <a:solidFill>
-                        <a:srgbClr val="000000"/>
+                        <a:srgbClr val="D9D9D9"/>
                       </a:solidFill>
                       <a:prstDash val="solid"/>
                       <a:round/>
@@ -6805,7 +6836,7 @@
                     </a:lnT>
                     <a:lnB w="6350" cap="flat" cmpd="sng" algn="ctr">
                       <a:solidFill>
-                        <a:srgbClr val="000000"/>
+                        <a:srgbClr val="D9D9D9"/>
                       </a:solidFill>
                       <a:prstDash val="solid"/>
                       <a:round/>
@@ -6838,7 +6869,7 @@
                   <a:tcPr marL="9525" marR="9525" marT="9525" marB="0" anchor="b">
                     <a:lnL w="6350" cap="flat" cmpd="sng" algn="ctr">
                       <a:solidFill>
-                        <a:srgbClr val="000000"/>
+                        <a:srgbClr val="D9D9D9"/>
                       </a:solidFill>
                       <a:prstDash val="solid"/>
                       <a:round/>
@@ -6847,7 +6878,7 @@
                     </a:lnL>
                     <a:lnR w="6350" cap="flat" cmpd="sng" algn="ctr">
                       <a:solidFill>
-                        <a:srgbClr val="000000"/>
+                        <a:srgbClr val="D9D9D9"/>
                       </a:solidFill>
                       <a:prstDash val="solid"/>
                       <a:round/>
@@ -6856,7 +6887,7 @@
                     </a:lnR>
                     <a:lnT w="6350" cap="flat" cmpd="sng" algn="ctr">
                       <a:solidFill>
-                        <a:srgbClr val="000000"/>
+                        <a:srgbClr val="D9D9D9"/>
                       </a:solidFill>
                       <a:prstDash val="solid"/>
                       <a:round/>
@@ -6865,7 +6896,7 @@
                     </a:lnT>
                     <a:lnB w="6350" cap="flat" cmpd="sng" algn="ctr">
                       <a:solidFill>
-                        <a:srgbClr val="000000"/>
+                        <a:srgbClr val="D9D9D9"/>
                       </a:solidFill>
                       <a:prstDash val="solid"/>
                       <a:round/>
@@ -6898,7 +6929,7 @@
                   <a:tcPr marL="9525" marR="9525" marT="9525" marB="0" anchor="b">
                     <a:lnL w="6350" cap="flat" cmpd="sng" algn="ctr">
                       <a:solidFill>
-                        <a:srgbClr val="000000"/>
+                        <a:srgbClr val="D9D9D9"/>
                       </a:solidFill>
                       <a:prstDash val="solid"/>
                       <a:round/>
@@ -6907,7 +6938,7 @@
                     </a:lnL>
                     <a:lnR w="6350" cap="flat" cmpd="sng" algn="ctr">
                       <a:solidFill>
-                        <a:srgbClr val="000000"/>
+                        <a:srgbClr val="D9D9D9"/>
                       </a:solidFill>
                       <a:prstDash val="solid"/>
                       <a:round/>
@@ -6916,7 +6947,7 @@
                     </a:lnR>
                     <a:lnT w="6350" cap="flat" cmpd="sng" algn="ctr">
                       <a:solidFill>
-                        <a:srgbClr val="000000"/>
+                        <a:srgbClr val="D9D9D9"/>
                       </a:solidFill>
                       <a:prstDash val="solid"/>
                       <a:round/>
@@ -6925,7 +6956,7 @@
                     </a:lnT>
                     <a:lnB w="6350" cap="flat" cmpd="sng" algn="ctr">
                       <a:solidFill>
-                        <a:srgbClr val="000000"/>
+                        <a:srgbClr val="D9D9D9"/>
                       </a:solidFill>
                       <a:prstDash val="solid"/>
                       <a:round/>
@@ -6944,9 +6975,9 @@
                         <a:buNone/>
                       </a:pPr>
                       <a:r>
-                        <a:rPr lang="he-IL" sz="1000" b="0" i="0" u="none" strike="noStrike" dirty="0">
+                        <a:rPr lang="he-IL" sz="1000" b="1" i="0" u="none" strike="noStrike" dirty="0">
                           <a:solidFill>
-                            <a:srgbClr val="000000"/>
+                            <a:srgbClr val="E0A62B"/>
                           </a:solidFill>
                           <a:effectLst/>
                           <a:latin typeface="Arial" panose="020B0604020202020204" pitchFamily="34" charset="0"/>
@@ -6958,7 +6989,7 @@
                   <a:tcPr marL="9525" marR="9525" marT="9525" marB="0" anchor="b">
                     <a:lnL w="6350" cap="flat" cmpd="sng" algn="ctr">
                       <a:solidFill>
-                        <a:srgbClr val="000000"/>
+                        <a:srgbClr val="D9D9D9"/>
                       </a:solidFill>
                       <a:prstDash val="solid"/>
                       <a:round/>
@@ -6967,7 +6998,7 @@
                     </a:lnL>
                     <a:lnR w="6350" cap="flat" cmpd="sng" algn="ctr">
                       <a:solidFill>
-                        <a:srgbClr val="000000"/>
+                        <a:srgbClr val="D9D9D9"/>
                       </a:solidFill>
                       <a:prstDash val="solid"/>
                       <a:round/>
@@ -6976,7 +7007,7 @@
                     </a:lnR>
                     <a:lnT w="6350" cap="flat" cmpd="sng" algn="ctr">
                       <a:solidFill>
-                        <a:srgbClr val="000000"/>
+                        <a:srgbClr val="D9D9D9"/>
                       </a:solidFill>
                       <a:prstDash val="solid"/>
                       <a:round/>
@@ -6985,7 +7016,7 @@
                     </a:lnT>
                     <a:lnB w="6350" cap="flat" cmpd="sng" algn="ctr">
                       <a:solidFill>
-                        <a:srgbClr val="000000"/>
+                        <a:srgbClr val="D9D9D9"/>
                       </a:solidFill>
                       <a:prstDash val="solid"/>
                       <a:round/>
@@ -7025,7 +7056,7 @@
                   <a:tcPr marL="9525" marR="9525" marT="9525" marB="0" anchor="b">
                     <a:lnL w="6350" cap="flat" cmpd="sng" algn="ctr">
                       <a:solidFill>
-                        <a:srgbClr val="000000"/>
+                        <a:srgbClr val="D9D9D9"/>
                       </a:solidFill>
                       <a:prstDash val="solid"/>
                       <a:round/>
@@ -7034,7 +7065,7 @@
                     </a:lnL>
                     <a:lnR w="6350" cap="flat" cmpd="sng" algn="ctr">
                       <a:solidFill>
-                        <a:srgbClr val="000000"/>
+                        <a:srgbClr val="D9D9D9"/>
                       </a:solidFill>
                       <a:prstDash val="solid"/>
                       <a:round/>
@@ -7043,7 +7074,7 @@
                     </a:lnR>
                     <a:lnT w="6350" cap="flat" cmpd="sng" algn="ctr">
                       <a:solidFill>
-                        <a:srgbClr val="000000"/>
+                        <a:srgbClr val="D9D9D9"/>
                       </a:solidFill>
                       <a:prstDash val="solid"/>
                       <a:round/>
@@ -7052,7 +7083,7 @@
                     </a:lnT>
                     <a:lnB w="6350" cap="flat" cmpd="sng" algn="ctr">
                       <a:solidFill>
-                        <a:srgbClr val="000000"/>
+                        <a:srgbClr val="D9D9D9"/>
                       </a:solidFill>
                       <a:prstDash val="solid"/>
                       <a:round/>
@@ -7085,7 +7116,7 @@
                   <a:tcPr marL="9525" marR="9525" marT="9525" marB="0" anchor="b">
                     <a:lnL w="6350" cap="flat" cmpd="sng" algn="ctr">
                       <a:solidFill>
-                        <a:srgbClr val="000000"/>
+                        <a:srgbClr val="D9D9D9"/>
                       </a:solidFill>
                       <a:prstDash val="solid"/>
                       <a:round/>
@@ -7094,7 +7125,7 @@
                     </a:lnL>
                     <a:lnR w="6350" cap="flat" cmpd="sng" algn="ctr">
                       <a:solidFill>
-                        <a:srgbClr val="000000"/>
+                        <a:srgbClr val="D9D9D9"/>
                       </a:solidFill>
                       <a:prstDash val="solid"/>
                       <a:round/>
@@ -7103,7 +7134,7 @@
                     </a:lnR>
                     <a:lnT w="6350" cap="flat" cmpd="sng" algn="ctr">
                       <a:solidFill>
-                        <a:srgbClr val="000000"/>
+                        <a:srgbClr val="D9D9D9"/>
                       </a:solidFill>
                       <a:prstDash val="solid"/>
                       <a:round/>
@@ -7112,7 +7143,7 @@
                     </a:lnT>
                     <a:lnB w="6350" cap="flat" cmpd="sng" algn="ctr">
                       <a:solidFill>
-                        <a:srgbClr val="000000"/>
+                        <a:srgbClr val="D9D9D9"/>
                       </a:solidFill>
                       <a:prstDash val="solid"/>
                       <a:round/>
@@ -7145,7 +7176,7 @@
                   <a:tcPr marL="9525" marR="9525" marT="9525" marB="0" anchor="b">
                     <a:lnL w="6350" cap="flat" cmpd="sng" algn="ctr">
                       <a:solidFill>
-                        <a:srgbClr val="000000"/>
+                        <a:srgbClr val="D9D9D9"/>
                       </a:solidFill>
                       <a:prstDash val="solid"/>
                       <a:round/>
@@ -7154,7 +7185,7 @@
                     </a:lnL>
                     <a:lnR w="6350" cap="flat" cmpd="sng" algn="ctr">
                       <a:solidFill>
-                        <a:srgbClr val="000000"/>
+                        <a:srgbClr val="D9D9D9"/>
                       </a:solidFill>
                       <a:prstDash val="solid"/>
                       <a:round/>
@@ -7163,7 +7194,7 @@
                     </a:lnR>
                     <a:lnT w="6350" cap="flat" cmpd="sng" algn="ctr">
                       <a:solidFill>
-                        <a:srgbClr val="000000"/>
+                        <a:srgbClr val="D9D9D9"/>
                       </a:solidFill>
                       <a:prstDash val="solid"/>
                       <a:round/>
@@ -7172,7 +7203,7 @@
                     </a:lnT>
                     <a:lnB w="6350" cap="flat" cmpd="sng" algn="ctr">
                       <a:solidFill>
-                        <a:srgbClr val="000000"/>
+                        <a:srgbClr val="D9D9D9"/>
                       </a:solidFill>
                       <a:prstDash val="solid"/>
                       <a:round/>
@@ -7191,9 +7222,9 @@
                         <a:buNone/>
                       </a:pPr>
                       <a:r>
-                        <a:rPr lang="he-IL" sz="1000" b="0" i="0" u="none" strike="noStrike" dirty="0">
+                        <a:rPr lang="he-IL" sz="1000" b="1" i="0" u="none" strike="noStrike" dirty="0">
                           <a:solidFill>
-                            <a:srgbClr val="000000"/>
+                            <a:srgbClr val="E0A62B"/>
                           </a:solidFill>
                           <a:effectLst/>
                           <a:latin typeface="Arial" panose="020B0604020202020204" pitchFamily="34" charset="0"/>
@@ -7205,7 +7236,7 @@
                   <a:tcPr marL="9525" marR="9525" marT="9525" marB="0" anchor="b">
                     <a:lnL w="6350" cap="flat" cmpd="sng" algn="ctr">
                       <a:solidFill>
-                        <a:srgbClr val="000000"/>
+                        <a:srgbClr val="D9D9D9"/>
                       </a:solidFill>
                       <a:prstDash val="solid"/>
                       <a:round/>
@@ -7214,7 +7245,7 @@
                     </a:lnL>
                     <a:lnR w="6350" cap="flat" cmpd="sng" algn="ctr">
                       <a:solidFill>
-                        <a:srgbClr val="000000"/>
+                        <a:srgbClr val="D9D9D9"/>
                       </a:solidFill>
                       <a:prstDash val="solid"/>
                       <a:round/>
@@ -7223,7 +7254,7 @@
                     </a:lnR>
                     <a:lnT w="6350" cap="flat" cmpd="sng" algn="ctr">
                       <a:solidFill>
-                        <a:srgbClr val="000000"/>
+                        <a:srgbClr val="D9D9D9"/>
                       </a:solidFill>
                       <a:prstDash val="solid"/>
                       <a:round/>
@@ -7232,7 +7263,7 @@
                     </a:lnT>
                     <a:lnB w="6350" cap="flat" cmpd="sng" algn="ctr">
                       <a:solidFill>
-                        <a:srgbClr val="000000"/>
+                        <a:srgbClr val="D9D9D9"/>
                       </a:solidFill>
                       <a:prstDash val="solid"/>
                       <a:round/>
@@ -7272,7 +7303,7 @@
                   <a:tcPr marL="9525" marR="9525" marT="9525" marB="0" anchor="b">
                     <a:lnL w="6350" cap="flat" cmpd="sng" algn="ctr">
                       <a:solidFill>
-                        <a:srgbClr val="000000"/>
+                        <a:srgbClr val="D9D9D9"/>
                       </a:solidFill>
                       <a:prstDash val="solid"/>
                       <a:round/>
@@ -7281,7 +7312,7 @@
                     </a:lnL>
                     <a:lnR w="6350" cap="flat" cmpd="sng" algn="ctr">
                       <a:solidFill>
-                        <a:srgbClr val="000000"/>
+                        <a:srgbClr val="D9D9D9"/>
                       </a:solidFill>
                       <a:prstDash val="solid"/>
                       <a:round/>
@@ -7290,7 +7321,7 @@
                     </a:lnR>
                     <a:lnT w="6350" cap="flat" cmpd="sng" algn="ctr">
                       <a:solidFill>
-                        <a:srgbClr val="000000"/>
+                        <a:srgbClr val="D9D9D9"/>
                       </a:solidFill>
                       <a:prstDash val="solid"/>
                       <a:round/>
@@ -7299,7 +7330,7 @@
                     </a:lnT>
                     <a:lnB w="6350" cap="flat" cmpd="sng" algn="ctr">
                       <a:solidFill>
-                        <a:srgbClr val="000000"/>
+                        <a:srgbClr val="D9D9D9"/>
                       </a:solidFill>
                       <a:prstDash val="solid"/>
                       <a:round/>
@@ -7332,7 +7363,7 @@
                   <a:tcPr marL="9525" marR="9525" marT="9525" marB="0" anchor="b">
                     <a:lnL w="6350" cap="flat" cmpd="sng" algn="ctr">
                       <a:solidFill>
-                        <a:srgbClr val="000000"/>
+                        <a:srgbClr val="D9D9D9"/>
                       </a:solidFill>
                       <a:prstDash val="solid"/>
                       <a:round/>
@@ -7341,7 +7372,7 @@
                     </a:lnL>
                     <a:lnR w="6350" cap="flat" cmpd="sng" algn="ctr">
                       <a:solidFill>
-                        <a:srgbClr val="000000"/>
+                        <a:srgbClr val="D9D9D9"/>
                       </a:solidFill>
                       <a:prstDash val="solid"/>
                       <a:round/>
@@ -7350,7 +7381,7 @@
                     </a:lnR>
                     <a:lnT w="6350" cap="flat" cmpd="sng" algn="ctr">
                       <a:solidFill>
-                        <a:srgbClr val="000000"/>
+                        <a:srgbClr val="D9D9D9"/>
                       </a:solidFill>
                       <a:prstDash val="solid"/>
                       <a:round/>
@@ -7359,7 +7390,7 @@
                     </a:lnT>
                     <a:lnB w="6350" cap="flat" cmpd="sng" algn="ctr">
                       <a:solidFill>
-                        <a:srgbClr val="000000"/>
+                        <a:srgbClr val="D9D9D9"/>
                       </a:solidFill>
                       <a:prstDash val="solid"/>
                       <a:round/>
@@ -7392,7 +7423,7 @@
                   <a:tcPr marL="9525" marR="9525" marT="9525" marB="0" anchor="b">
                     <a:lnL w="6350" cap="flat" cmpd="sng" algn="ctr">
                       <a:solidFill>
-                        <a:srgbClr val="000000"/>
+                        <a:srgbClr val="D9D9D9"/>
                       </a:solidFill>
                       <a:prstDash val="solid"/>
                       <a:round/>
@@ -7401,7 +7432,7 @@
                     </a:lnL>
                     <a:lnR w="6350" cap="flat" cmpd="sng" algn="ctr">
                       <a:solidFill>
-                        <a:srgbClr val="000000"/>
+                        <a:srgbClr val="D9D9D9"/>
                       </a:solidFill>
                       <a:prstDash val="solid"/>
                       <a:round/>
@@ -7410,7 +7441,7 @@
                     </a:lnR>
                     <a:lnT w="6350" cap="flat" cmpd="sng" algn="ctr">
                       <a:solidFill>
-                        <a:srgbClr val="000000"/>
+                        <a:srgbClr val="D9D9D9"/>
                       </a:solidFill>
                       <a:prstDash val="solid"/>
                       <a:round/>
@@ -7419,7 +7450,7 @@
                     </a:lnT>
                     <a:lnB w="6350" cap="flat" cmpd="sng" algn="ctr">
                       <a:solidFill>
-                        <a:srgbClr val="000000"/>
+                        <a:srgbClr val="D9D9D9"/>
                       </a:solidFill>
                       <a:prstDash val="solid"/>
                       <a:round/>
@@ -7438,9 +7469,9 @@
                         <a:buNone/>
                       </a:pPr>
                       <a:r>
-                        <a:rPr lang="he-IL" sz="1000" b="0" i="0" u="none" strike="noStrike" dirty="0">
+                        <a:rPr lang="he-IL" sz="1000" b="1" i="0" u="none" strike="noStrike" dirty="0">
                           <a:solidFill>
-                            <a:srgbClr val="000000"/>
+                            <a:srgbClr val="E0A62B"/>
                           </a:solidFill>
                           <a:effectLst/>
                           <a:latin typeface="Arial" panose="020B0604020202020204" pitchFamily="34" charset="0"/>
@@ -7452,7 +7483,7 @@
                   <a:tcPr marL="9525" marR="9525" marT="9525" marB="0" anchor="b">
                     <a:lnL w="6350" cap="flat" cmpd="sng" algn="ctr">
                       <a:solidFill>
-                        <a:srgbClr val="000000"/>
+                        <a:srgbClr val="D9D9D9"/>
                       </a:solidFill>
                       <a:prstDash val="solid"/>
                       <a:round/>
@@ -7461,7 +7492,7 @@
                     </a:lnL>
                     <a:lnR w="6350" cap="flat" cmpd="sng" algn="ctr">
                       <a:solidFill>
-                        <a:srgbClr val="000000"/>
+                        <a:srgbClr val="D9D9D9"/>
                       </a:solidFill>
                       <a:prstDash val="solid"/>
                       <a:round/>
@@ -7470,7 +7501,7 @@
                     </a:lnR>
                     <a:lnT w="6350" cap="flat" cmpd="sng" algn="ctr">
                       <a:solidFill>
-                        <a:srgbClr val="000000"/>
+                        <a:srgbClr val="D9D9D9"/>
                       </a:solidFill>
                       <a:prstDash val="solid"/>
                       <a:round/>
@@ -7479,7 +7510,7 @@
                     </a:lnT>
                     <a:lnB w="6350" cap="flat" cmpd="sng" algn="ctr">
                       <a:solidFill>
-                        <a:srgbClr val="000000"/>
+                        <a:srgbClr val="D9D9D9"/>
                       </a:solidFill>
                       <a:prstDash val="solid"/>
                       <a:round/>
@@ -7507,7 +7538,7 @@
                       <a:r>
                         <a:rPr lang="he-IL" sz="1000" b="1" i="0" u="none" strike="noStrike">
                           <a:solidFill>
-                            <a:srgbClr val="000000"/>
+                            <a:srgbClr val="002F6C"/>
                           </a:solidFill>
                           <a:effectLst/>
                           <a:latin typeface="Arial" panose="020B0604020202020204" pitchFamily="34" charset="0"/>
@@ -7519,7 +7550,7 @@
                   <a:tcPr marL="9525" marR="9525" marT="9525" marB="0" anchor="b">
                     <a:lnL w="6350" cap="flat" cmpd="sng" algn="ctr">
                       <a:solidFill>
-                        <a:srgbClr val="000000"/>
+                        <a:srgbClr val="DCE3EE"/>
                       </a:solidFill>
                       <a:prstDash val="solid"/>
                       <a:round/>
@@ -7528,16 +7559,16 @@
                     </a:lnL>
                     <a:lnR w="6350" cap="flat" cmpd="sng" algn="ctr">
                       <a:solidFill>
-                        <a:srgbClr val="000000"/>
+                        <a:srgbClr val="DCE3EE"/>
                       </a:solidFill>
                       <a:prstDash val="solid"/>
                       <a:round/>
                       <a:headEnd type="none" w="med" len="med"/>
                       <a:tailEnd type="none" w="med" len="med"/>
                     </a:lnR>
-                    <a:lnT w="6350" cap="flat" cmpd="sng" algn="ctr">
-                      <a:solidFill>
-                        <a:srgbClr val="000000"/>
+                    <a:lnT w="28575" cap="flat" cmpd="sng" algn="ctr">
+                      <a:solidFill>
+                        <a:srgbClr val="002F6C"/>
                       </a:solidFill>
                       <a:prstDash val="solid"/>
                       <a:round/>
@@ -7546,14 +7577,16 @@
                     </a:lnT>
                     <a:lnB w="6350" cap="flat" cmpd="sng" algn="ctr">
                       <a:solidFill>
-                        <a:srgbClr val="000000"/>
+                        <a:srgbClr val="DCE3EE"/>
                       </a:solidFill>
                       <a:prstDash val="solid"/>
                       <a:round/>
                       <a:headEnd type="none" w="med" len="med"/>
                       <a:tailEnd type="none" w="med" len="med"/>
                     </a:lnB>
-                    <a:noFill/>
+                    <a:solidFill>
+                      <a:srgbClr val="DCE3EE"/>
+                    </a:solidFill>
                   </a:tcPr>
                 </a:tc>
                 <a:tc>
@@ -7567,7 +7600,7 @@
                       <a:r>
                         <a:rPr lang="he-IL" sz="1000" b="1" i="0" u="none" strike="noStrike">
                           <a:solidFill>
-                            <a:srgbClr val="000000"/>
+                            <a:srgbClr val="002F6C"/>
                           </a:solidFill>
                           <a:effectLst/>
                           <a:latin typeface="Arial" panose="020B0604020202020204" pitchFamily="34" charset="0"/>
@@ -7579,7 +7612,7 @@
                   <a:tcPr marL="9525" marR="9525" marT="9525" marB="0" anchor="b">
                     <a:lnL w="6350" cap="flat" cmpd="sng" algn="ctr">
                       <a:solidFill>
-                        <a:srgbClr val="000000"/>
+                        <a:srgbClr val="DCE3EE"/>
                       </a:solidFill>
                       <a:prstDash val="solid"/>
                       <a:round/>
@@ -7588,16 +7621,16 @@
                     </a:lnL>
                     <a:lnR w="6350" cap="flat" cmpd="sng" algn="ctr">
                       <a:solidFill>
-                        <a:srgbClr val="000000"/>
+                        <a:srgbClr val="DCE3EE"/>
                       </a:solidFill>
                       <a:prstDash val="solid"/>
                       <a:round/>
                       <a:headEnd type="none" w="med" len="med"/>
                       <a:tailEnd type="none" w="med" len="med"/>
                     </a:lnR>
-                    <a:lnT w="6350" cap="flat" cmpd="sng" algn="ctr">
-                      <a:solidFill>
-                        <a:srgbClr val="000000"/>
+                    <a:lnT w="28575" cap="flat" cmpd="sng" algn="ctr">
+                      <a:solidFill>
+                        <a:srgbClr val="002F6C"/>
                       </a:solidFill>
                       <a:prstDash val="solid"/>
                       <a:round/>
@@ -7606,14 +7639,16 @@
                     </a:lnT>
                     <a:lnB w="6350" cap="flat" cmpd="sng" algn="ctr">
                       <a:solidFill>
-                        <a:srgbClr val="000000"/>
+                        <a:srgbClr val="DCE3EE"/>
                       </a:solidFill>
                       <a:prstDash val="solid"/>
                       <a:round/>
                       <a:headEnd type="none" w="med" len="med"/>
                       <a:tailEnd type="none" w="med" len="med"/>
                     </a:lnB>
-                    <a:noFill/>
+                    <a:solidFill>
+                      <a:srgbClr val="DCE3EE"/>
+                    </a:solidFill>
                   </a:tcPr>
                 </a:tc>
                 <a:tc>
@@ -7627,7 +7662,7 @@
                       <a:r>
                         <a:rPr lang="he-IL" sz="1000" b="1" i="0" u="none" strike="noStrike">
                           <a:solidFill>
-                            <a:srgbClr val="000000"/>
+                            <a:srgbClr val="002F6C"/>
                           </a:solidFill>
                           <a:effectLst/>
                           <a:latin typeface="Arial" panose="020B0604020202020204" pitchFamily="34" charset="0"/>
@@ -7639,7 +7674,7 @@
                   <a:tcPr marL="9525" marR="9525" marT="9525" marB="0" anchor="b">
                     <a:lnL w="6350" cap="flat" cmpd="sng" algn="ctr">
                       <a:solidFill>
-                        <a:srgbClr val="000000"/>
+                        <a:srgbClr val="DCE3EE"/>
                       </a:solidFill>
                       <a:prstDash val="solid"/>
                       <a:round/>
@@ -7648,16 +7683,16 @@
                     </a:lnL>
                     <a:lnR w="6350" cap="flat" cmpd="sng" algn="ctr">
                       <a:solidFill>
-                        <a:srgbClr val="000000"/>
+                        <a:srgbClr val="DCE3EE"/>
                       </a:solidFill>
                       <a:prstDash val="solid"/>
                       <a:round/>
                       <a:headEnd type="none" w="med" len="med"/>
                       <a:tailEnd type="none" w="med" len="med"/>
                     </a:lnR>
-                    <a:lnT w="6350" cap="flat" cmpd="sng" algn="ctr">
-                      <a:solidFill>
-                        <a:srgbClr val="000000"/>
+                    <a:lnT w="28575" cap="flat" cmpd="sng" algn="ctr">
+                      <a:solidFill>
+                        <a:srgbClr val="002F6C"/>
                       </a:solidFill>
                       <a:prstDash val="solid"/>
                       <a:round/>
@@ -7666,14 +7701,16 @@
                     </a:lnT>
                     <a:lnB w="6350" cap="flat" cmpd="sng" algn="ctr">
                       <a:solidFill>
-                        <a:srgbClr val="000000"/>
+                        <a:srgbClr val="DCE3EE"/>
                       </a:solidFill>
                       <a:prstDash val="solid"/>
                       <a:round/>
                       <a:headEnd type="none" w="med" len="med"/>
                       <a:tailEnd type="none" w="med" len="med"/>
                     </a:lnB>
-                    <a:noFill/>
+                    <a:solidFill>
+                      <a:srgbClr val="DCE3EE"/>
+                    </a:solidFill>
                   </a:tcPr>
                 </a:tc>
                 <a:tc>
@@ -7687,7 +7724,7 @@
                       <a:r>
                         <a:rPr lang="he-IL" sz="1000" b="1" i="0" u="none" strike="noStrike" dirty="0">
                           <a:solidFill>
-                            <a:srgbClr val="000000"/>
+                            <a:srgbClr val="002F6C"/>
                           </a:solidFill>
                           <a:effectLst/>
                           <a:latin typeface="Arial" panose="020B0604020202020204" pitchFamily="34" charset="0"/>
@@ -7699,7 +7736,7 @@
                   <a:tcPr marL="9525" marR="9525" marT="9525" marB="0" anchor="b">
                     <a:lnL w="6350" cap="flat" cmpd="sng" algn="ctr">
                       <a:solidFill>
-                        <a:srgbClr val="000000"/>
+                        <a:srgbClr val="DCE3EE"/>
                       </a:solidFill>
                       <a:prstDash val="solid"/>
                       <a:round/>
@@ -7708,16 +7745,16 @@
                     </a:lnL>
                     <a:lnR w="6350" cap="flat" cmpd="sng" algn="ctr">
                       <a:solidFill>
-                        <a:srgbClr val="000000"/>
+                        <a:srgbClr val="DCE3EE"/>
                       </a:solidFill>
                       <a:prstDash val="solid"/>
                       <a:round/>
                       <a:headEnd type="none" w="med" len="med"/>
                       <a:tailEnd type="none" w="med" len="med"/>
                     </a:lnR>
-                    <a:lnT w="6350" cap="flat" cmpd="sng" algn="ctr">
-                      <a:solidFill>
-                        <a:srgbClr val="000000"/>
+                    <a:lnT w="28575" cap="flat" cmpd="sng" algn="ctr">
+                      <a:solidFill>
+                        <a:srgbClr val="002F6C"/>
                       </a:solidFill>
                       <a:prstDash val="solid"/>
                       <a:round/>
@@ -7726,14 +7763,16 @@
                     </a:lnT>
                     <a:lnB w="6350" cap="flat" cmpd="sng" algn="ctr">
                       <a:solidFill>
-                        <a:srgbClr val="000000"/>
+                        <a:srgbClr val="DCE3EE"/>
                       </a:solidFill>
                       <a:prstDash val="solid"/>
                       <a:round/>
                       <a:headEnd type="none" w="med" len="med"/>
                       <a:tailEnd type="none" w="med" len="med"/>
                     </a:lnB>
-                    <a:noFill/>
+                    <a:solidFill>
+                      <a:srgbClr val="DCE3EE"/>
+                    </a:solidFill>
                   </a:tcPr>
                 </a:tc>
                 <a:extLst>
@@ -7790,8 +7829,8 @@
         </p:nvSpPr>
         <p:spPr>
           <a:xfrm>
-            <a:off x="4797012" y="4698149"/>
-            <a:ext cx="5810448" cy="335156"/>
+            <a:off x="4797012" y="4591407"/>
+            <a:ext cx="5810448" cy="548640"/>
           </a:xfrm>
           <a:prstGeom prst="rect">
             <a:avLst/>
@@ -7804,21 +7843,40 @@
           </a:bodyPr>
           <a:lstStyle/>
           <a:p>
-            <a:pPr>
+            <a:pPr algn="ctr">
               <a:lnSpc>
                 <a:spcPct val="150000"/>
               </a:lnSpc>
             </a:pPr>
             <a:r>
-              <a:rPr lang="he-IL" sz="1200" b="1" dirty="0">
+              <a:rPr lang="he-IL" sz="1400" b="1" kern="0" dirty="0">
+                <a:solidFill>
+                  <a:srgbClr val="5B6B82"/>
+                </a:solidFill>
+                <a:latin typeface="Arial"/>
+                <a:cs typeface="Arial" panose="020B0604020202020204" pitchFamily="34" charset="0"/>
+              </a:rPr>
+              <a:t>עמידה ב </a:t>
+            </a:r>
+            <a:r>
+              <a:rPr lang="he-IL" sz="3200" b="1" kern="0" dirty="0">
                 <a:solidFill>
                   <a:srgbClr val="002F6C"/>
                 </a:solidFill>
-                <a:latin typeface="+mn-lt"/>
-                <a:ea typeface="+mn-ea"/>
-                <a:cs typeface="+mn-cs"/>
+                <a:latin typeface="Arial"/>
+                <a:cs typeface="Arial" panose="020B0604020202020204" pitchFamily="34" charset="0"/>
               </a:rPr>
-              <a:t>עמידה ב 86% מיעד המטרה </a:t>
+              <a:t>86%</a:t>
+            </a:r>
+            <a:r>
+              <a:rPr lang="he-IL" sz="1400" b="1" kern="0" dirty="0">
+                <a:solidFill>
+                  <a:srgbClr val="5B6B82"/>
+                </a:solidFill>
+                <a:latin typeface="Arial"/>
+                <a:cs typeface="Arial" panose="020B0604020202020204" pitchFamily="34" charset="0"/>
+              </a:rPr>
+              <a:t> מיעד המטרה </a:t>
             </a:r>
           </a:p>
         </p:txBody>

</xml_diff>

<commit_message>
Add 3-slide deck with user's slide 2 edits and new slide 3 pie chart
Co-Authored-By: Claude Sonnet 5 <noreply@anthropic.com>
Claude-Session: https://claude.ai/code/session_01E9QvuhBZminJvrtKVH8YY8
</commit_message>
<xml_diff>
--- a/svetlana/outputs/2026-10-27-מכירות-סטטוס-ותחזית-2026.pptx
+++ b/svetlana/outputs/2026-10-27-מכירות-סטטוס-ותחזית-2026.pptx
@@ -7,6 +7,7 @@
   <p:sldIdLst>
     <p:sldId id="324" r:id="rId2"/>
     <p:sldId id="325" r:id="rId3"/>
+    <p:sldId id="326" r:id="rId4"/>
   </p:sldIdLst>
   <p:sldSz cx="12192000" cy="6858000"/>
   <p:notesSz cx="6858000" cy="9144000"/>
@@ -390,7 +391,7 @@
               <a:lstStyle/>
               <a:p>
                 <a:pPr>
-                  <a:defRPr sz="800" b="1" i="0" u="none" strike="noStrike" kern="1200" baseline="0">
+                  <a:defRPr sz="600" b="1" i="0" u="none" strike="noStrike" kern="1200" baseline="0">
                     <a:solidFill>
                       <a:srgbClr val="5B6B82"/>
                     </a:solidFill>
@@ -694,6 +695,7 @@
           <c:dPt>
             <c:idx val="0"/>
             <c:invertIfNegative val="0"/>
+            <c:bubble3D val="0"/>
             <c:spPr>
               <a:solidFill>
                 <a:srgbClr val="D9D9D9"/>
@@ -703,10 +705,16 @@
               </a:ln>
               <a:effectLst/>
             </c:spPr>
+            <c:extLst>
+              <c:ext xmlns:c16="http://schemas.microsoft.com/office/drawing/2014/chart" uri="{C3380CC4-5D6E-409C-BE32-E72D297353CC}">
+                <c16:uniqueId val="{00000001-6F0C-4C4D-A0B0-DAC7E85AB14B}"/>
+              </c:ext>
+            </c:extLst>
           </c:dPt>
           <c:dPt>
             <c:idx val="1"/>
             <c:invertIfNegative val="0"/>
+            <c:bubble3D val="0"/>
             <c:spPr>
               <a:solidFill>
                 <a:srgbClr val="5B6B82"/>
@@ -716,10 +724,16 @@
               </a:ln>
               <a:effectLst/>
             </c:spPr>
+            <c:extLst>
+              <c:ext xmlns:c16="http://schemas.microsoft.com/office/drawing/2014/chart" uri="{C3380CC4-5D6E-409C-BE32-E72D297353CC}">
+                <c16:uniqueId val="{00000003-6F0C-4C4D-A0B0-DAC7E85AB14B}"/>
+              </c:ext>
+            </c:extLst>
           </c:dPt>
           <c:dPt>
             <c:idx val="2"/>
             <c:invertIfNegative val="0"/>
+            <c:bubble3D val="0"/>
             <c:spPr>
               <a:solidFill>
                 <a:srgbClr val="002F6C"/>
@@ -729,6 +743,11 @@
               </a:ln>
               <a:effectLst/>
             </c:spPr>
+            <c:extLst>
+              <c:ext xmlns:c16="http://schemas.microsoft.com/office/drawing/2014/chart" uri="{C3380CC4-5D6E-409C-BE32-E72D297353CC}">
+                <c16:uniqueId val="{00000005-6F0C-4C4D-A0B0-DAC7E85AB14B}"/>
+              </c:ext>
+            </c:extLst>
           </c:dPt>
           <c:dLbls>
             <c:numFmt formatCode="0.0&quot;M&quot;" sourceLinked="0"/>
@@ -862,7 +881,7 @@
           <a:effectLst/>
         </c:spPr>
         <c:txPr>
-          <a:bodyPr rot="0" spcFirstLastPara="1" vertOverflow="ellipsis" vert="horz" wrap="square" anchor="ctr" anchorCtr="1"/>
+          <a:bodyPr rot="0" spcFirstLastPara="1" vertOverflow="ellipsis" wrap="square" anchor="ctr" anchorCtr="1"/>
           <a:lstStyle/>
           <a:p>
             <a:pPr>
@@ -908,6 +927,527 @@
         <a:effectLst/>
       </c:spPr>
     </c:plotArea>
+    <c:plotVisOnly val="1"/>
+    <c:dispBlanksAs val="gap"/>
+    <c:showDLblsOverMax val="0"/>
+    <c:extLst>
+      <c:ext xmlns:c16r3="http://schemas.microsoft.com/office/drawing/2017/03/chart" uri="{56B9EC1D-385E-4148-901F-78D8002777C0}">
+        <c16r3:dataDisplayOptions16>
+          <c16r3:dispNaAsBlank val="1"/>
+        </c16r3:dataDisplayOptions16>
+      </c:ext>
+    </c:extLst>
+  </c:chart>
+  <c:spPr>
+    <a:noFill/>
+    <a:ln>
+      <a:noFill/>
+    </a:ln>
+    <a:effectLst/>
+  </c:spPr>
+  <c:txPr>
+    <a:bodyPr/>
+    <a:lstStyle/>
+    <a:p>
+      <a:pPr>
+        <a:defRPr/>
+      </a:pPr>
+      <a:endParaRPr lang="he-IL"/>
+    </a:p>
+  </c:txPr>
+  <c:externalData r:id="rId3">
+    <c:autoUpdate val="0"/>
+  </c:externalData>
+</c:chartSpace>
+</file>
+
+<file path=ppt/charts/chart3.xml><?xml version="1.0" encoding="utf-8"?>
+<c:chartSpace xmlns:c="http://schemas.openxmlformats.org/drawingml/2006/chart" xmlns:a="http://schemas.openxmlformats.org/drawingml/2006/main" xmlns:r="http://schemas.openxmlformats.org/officeDocument/2006/relationships" xmlns:c16r2="http://schemas.microsoft.com/office/drawing/2015/06/chart">
+  <c:date1904 val="0"/>
+  <c:lang val="he-IL"/>
+  <c:roundedCorners val="0"/>
+  <mc:AlternateContent xmlns:mc="http://schemas.openxmlformats.org/markup-compatibility/2006">
+    <mc:Choice xmlns:c14="http://schemas.microsoft.com/office/drawing/2007/8/2/chart" Requires="c14">
+      <c14:style val="103"/>
+    </mc:Choice>
+    <mc:Fallback>
+      <c:style val="3"/>
+    </mc:Fallback>
+  </mc:AlternateContent>
+  <c:chart>
+    <c:autoTitleDeleted val="1"/>
+    <c:view3D>
+      <c:rotX val="30"/>
+      <c:rotY val="360"/>
+      <c:depthPercent val="100"/>
+      <c:rAngAx val="0"/>
+    </c:view3D>
+    <c:floor>
+      <c:thickness val="0"/>
+      <c:spPr>
+        <a:noFill/>
+        <a:ln>
+          <a:noFill/>
+        </a:ln>
+        <a:effectLst/>
+        <a:sp3d/>
+      </c:spPr>
+    </c:floor>
+    <c:sideWall>
+      <c:thickness val="0"/>
+      <c:spPr>
+        <a:noFill/>
+        <a:ln>
+          <a:noFill/>
+        </a:ln>
+        <a:effectLst/>
+        <a:sp3d/>
+      </c:spPr>
+    </c:sideWall>
+    <c:backWall>
+      <c:thickness val="0"/>
+      <c:spPr>
+        <a:noFill/>
+        <a:ln>
+          <a:noFill/>
+        </a:ln>
+        <a:effectLst/>
+        <a:sp3d/>
+      </c:spPr>
+    </c:backWall>
+    <c:plotArea>
+      <c:layout/>
+      <c:pie3DChart>
+        <c:varyColors val="1"/>
+        <c:ser>
+          <c:idx val="0"/>
+          <c:order val="0"/>
+          <c:dPt>
+            <c:idx val="0"/>
+            <c:bubble3D val="0"/>
+            <c:spPr>
+              <a:solidFill>
+                <a:schemeClr val="accent1">
+                  <a:shade val="44000"/>
+                </a:schemeClr>
+              </a:solidFill>
+              <a:ln w="25400">
+                <a:solidFill>
+                  <a:schemeClr val="lt1"/>
+                </a:solidFill>
+              </a:ln>
+              <a:effectLst/>
+              <a:sp3d contourW="25400">
+                <a:contourClr>
+                  <a:schemeClr val="lt1"/>
+                </a:contourClr>
+              </a:sp3d>
+            </c:spPr>
+            <c:extLst>
+              <c:ext xmlns:c16="http://schemas.microsoft.com/office/drawing/2014/chart" uri="{C3380CC4-5D6E-409C-BE32-E72D297353CC}">
+                <c16:uniqueId val="{00000001-1499-4A2F-A324-30BA285687A9}"/>
+              </c:ext>
+            </c:extLst>
+          </c:dPt>
+          <c:dPt>
+            <c:idx val="1"/>
+            <c:bubble3D val="0"/>
+            <c:spPr>
+              <a:solidFill>
+                <a:schemeClr val="accent1">
+                  <a:shade val="58000"/>
+                </a:schemeClr>
+              </a:solidFill>
+              <a:ln w="25400">
+                <a:solidFill>
+                  <a:schemeClr val="lt1"/>
+                </a:solidFill>
+              </a:ln>
+              <a:effectLst/>
+              <a:sp3d contourW="25400">
+                <a:contourClr>
+                  <a:schemeClr val="lt1"/>
+                </a:contourClr>
+              </a:sp3d>
+            </c:spPr>
+            <c:extLst>
+              <c:ext xmlns:c16="http://schemas.microsoft.com/office/drawing/2014/chart" uri="{C3380CC4-5D6E-409C-BE32-E72D297353CC}">
+                <c16:uniqueId val="{00000003-1499-4A2F-A324-30BA285687A9}"/>
+              </c:ext>
+            </c:extLst>
+          </c:dPt>
+          <c:dPt>
+            <c:idx val="2"/>
+            <c:bubble3D val="0"/>
+            <c:spPr>
+              <a:solidFill>
+                <a:schemeClr val="accent1">
+                  <a:shade val="72000"/>
+                </a:schemeClr>
+              </a:solidFill>
+              <a:ln w="25400">
+                <a:solidFill>
+                  <a:schemeClr val="lt1"/>
+                </a:solidFill>
+              </a:ln>
+              <a:effectLst/>
+              <a:sp3d contourW="25400">
+                <a:contourClr>
+                  <a:schemeClr val="lt1"/>
+                </a:contourClr>
+              </a:sp3d>
+            </c:spPr>
+            <c:extLst>
+              <c:ext xmlns:c16="http://schemas.microsoft.com/office/drawing/2014/chart" uri="{C3380CC4-5D6E-409C-BE32-E72D297353CC}">
+                <c16:uniqueId val="{00000005-1499-4A2F-A324-30BA285687A9}"/>
+              </c:ext>
+            </c:extLst>
+          </c:dPt>
+          <c:dPt>
+            <c:idx val="3"/>
+            <c:bubble3D val="0"/>
+            <c:spPr>
+              <a:solidFill>
+                <a:schemeClr val="accent1">
+                  <a:shade val="86000"/>
+                </a:schemeClr>
+              </a:solidFill>
+              <a:ln w="25400">
+                <a:solidFill>
+                  <a:schemeClr val="lt1"/>
+                </a:solidFill>
+              </a:ln>
+              <a:effectLst/>
+              <a:sp3d contourW="25400">
+                <a:contourClr>
+                  <a:schemeClr val="lt1"/>
+                </a:contourClr>
+              </a:sp3d>
+            </c:spPr>
+            <c:extLst>
+              <c:ext xmlns:c16="http://schemas.microsoft.com/office/drawing/2014/chart" uri="{C3380CC4-5D6E-409C-BE32-E72D297353CC}">
+                <c16:uniqueId val="{00000007-1499-4A2F-A324-30BA285687A9}"/>
+              </c:ext>
+            </c:extLst>
+          </c:dPt>
+          <c:dPt>
+            <c:idx val="4"/>
+            <c:bubble3D val="0"/>
+            <c:spPr>
+              <a:solidFill>
+                <a:schemeClr val="accent1"/>
+              </a:solidFill>
+              <a:ln w="25400">
+                <a:solidFill>
+                  <a:schemeClr val="lt1"/>
+                </a:solidFill>
+              </a:ln>
+              <a:effectLst/>
+              <a:sp3d contourW="25400">
+                <a:contourClr>
+                  <a:schemeClr val="lt1"/>
+                </a:contourClr>
+              </a:sp3d>
+            </c:spPr>
+            <c:extLst>
+              <c:ext xmlns:c16="http://schemas.microsoft.com/office/drawing/2014/chart" uri="{C3380CC4-5D6E-409C-BE32-E72D297353CC}">
+                <c16:uniqueId val="{00000009-1499-4A2F-A324-30BA285687A9}"/>
+              </c:ext>
+            </c:extLst>
+          </c:dPt>
+          <c:dPt>
+            <c:idx val="5"/>
+            <c:bubble3D val="0"/>
+            <c:spPr>
+              <a:solidFill>
+                <a:schemeClr val="accent1">
+                  <a:tint val="86000"/>
+                </a:schemeClr>
+              </a:solidFill>
+              <a:ln w="25400">
+                <a:solidFill>
+                  <a:schemeClr val="lt1"/>
+                </a:solidFill>
+              </a:ln>
+              <a:effectLst/>
+              <a:sp3d contourW="25400">
+                <a:contourClr>
+                  <a:schemeClr val="lt1"/>
+                </a:contourClr>
+              </a:sp3d>
+            </c:spPr>
+            <c:extLst>
+              <c:ext xmlns:c16="http://schemas.microsoft.com/office/drawing/2014/chart" uri="{C3380CC4-5D6E-409C-BE32-E72D297353CC}">
+                <c16:uniqueId val="{0000000B-1499-4A2F-A324-30BA285687A9}"/>
+              </c:ext>
+            </c:extLst>
+          </c:dPt>
+          <c:dPt>
+            <c:idx val="6"/>
+            <c:bubble3D val="0"/>
+            <c:spPr>
+              <a:solidFill>
+                <a:schemeClr val="accent1">
+                  <a:tint val="72000"/>
+                </a:schemeClr>
+              </a:solidFill>
+              <a:ln w="25400">
+                <a:solidFill>
+                  <a:schemeClr val="lt1"/>
+                </a:solidFill>
+              </a:ln>
+              <a:effectLst/>
+              <a:sp3d contourW="25400">
+                <a:contourClr>
+                  <a:schemeClr val="lt1"/>
+                </a:contourClr>
+              </a:sp3d>
+            </c:spPr>
+            <c:extLst>
+              <c:ext xmlns:c16="http://schemas.microsoft.com/office/drawing/2014/chart" uri="{C3380CC4-5D6E-409C-BE32-E72D297353CC}">
+                <c16:uniqueId val="{0000000D-1499-4A2F-A324-30BA285687A9}"/>
+              </c:ext>
+            </c:extLst>
+          </c:dPt>
+          <c:dPt>
+            <c:idx val="7"/>
+            <c:bubble3D val="0"/>
+            <c:spPr>
+              <a:solidFill>
+                <a:schemeClr val="accent1">
+                  <a:tint val="58000"/>
+                </a:schemeClr>
+              </a:solidFill>
+              <a:ln w="25400">
+                <a:solidFill>
+                  <a:schemeClr val="lt1"/>
+                </a:solidFill>
+              </a:ln>
+              <a:effectLst/>
+              <a:sp3d contourW="25400">
+                <a:contourClr>
+                  <a:schemeClr val="lt1"/>
+                </a:contourClr>
+              </a:sp3d>
+            </c:spPr>
+            <c:extLst>
+              <c:ext xmlns:c16="http://schemas.microsoft.com/office/drawing/2014/chart" uri="{C3380CC4-5D6E-409C-BE32-E72D297353CC}">
+                <c16:uniqueId val="{0000000F-1499-4A2F-A324-30BA285687A9}"/>
+              </c:ext>
+            </c:extLst>
+          </c:dPt>
+          <c:dPt>
+            <c:idx val="8"/>
+            <c:bubble3D val="0"/>
+            <c:spPr>
+              <a:solidFill>
+                <a:schemeClr val="accent1">
+                  <a:tint val="44000"/>
+                </a:schemeClr>
+              </a:solidFill>
+              <a:ln w="25400">
+                <a:solidFill>
+                  <a:schemeClr val="lt1"/>
+                </a:solidFill>
+              </a:ln>
+              <a:effectLst/>
+              <a:sp3d contourW="25400">
+                <a:contourClr>
+                  <a:schemeClr val="lt1"/>
+                </a:contourClr>
+              </a:sp3d>
+            </c:spPr>
+            <c:extLst>
+              <c:ext xmlns:c16="http://schemas.microsoft.com/office/drawing/2014/chart" uri="{C3380CC4-5D6E-409C-BE32-E72D297353CC}">
+                <c16:uniqueId val="{00000011-1499-4A2F-A324-30BA285687A9}"/>
+              </c:ext>
+            </c:extLst>
+          </c:dPt>
+          <c:dLbls>
+            <c:spPr>
+              <a:noFill/>
+              <a:ln>
+                <a:noFill/>
+              </a:ln>
+              <a:effectLst/>
+            </c:spPr>
+            <c:txPr>
+              <a:bodyPr rot="0" spcFirstLastPara="1" vertOverflow="ellipsis" vert="horz" wrap="square" lIns="38100" tIns="19050" rIns="38100" bIns="19050" anchor="ctr" anchorCtr="1">
+                <a:spAutoFit/>
+              </a:bodyPr>
+              <a:lstStyle/>
+              <a:p>
+                <a:pPr>
+                  <a:defRPr sz="900" b="0" i="0" u="none" strike="noStrike" kern="1200" baseline="0">
+                    <a:solidFill>
+                      <a:schemeClr val="tx1">
+                        <a:lumMod val="75000"/>
+                        <a:lumOff val="25000"/>
+                      </a:schemeClr>
+                    </a:solidFill>
+                    <a:latin typeface="+mn-lt"/>
+                    <a:ea typeface="+mn-ea"/>
+                    <a:cs typeface="+mn-cs"/>
+                  </a:defRPr>
+                </a:pPr>
+                <a:endParaRPr lang="he-IL"/>
+              </a:p>
+            </c:txPr>
+            <c:dLblPos val="outEnd"/>
+            <c:showLegendKey val="0"/>
+            <c:showVal val="1"/>
+            <c:showCatName val="0"/>
+            <c:showSerName val="0"/>
+            <c:showPercent val="0"/>
+            <c:showBubbleSize val="0"/>
+            <c:showLeaderLines val="1"/>
+            <c:leaderLines>
+              <c:spPr>
+                <a:ln w="9525" cap="flat" cmpd="sng" algn="ctr">
+                  <a:solidFill>
+                    <a:schemeClr val="tx1">
+                      <a:lumMod val="35000"/>
+                      <a:lumOff val="65000"/>
+                    </a:schemeClr>
+                  </a:solidFill>
+                  <a:round/>
+                </a:ln>
+                <a:effectLst/>
+              </c:spPr>
+            </c:leaderLines>
+            <c:extLst>
+              <c:ext xmlns:c15="http://schemas.microsoft.com/office/drawing/2012/chart" uri="{CE6537A1-D6FC-4f65-9D91-7224C49458BB}"/>
+            </c:extLst>
+          </c:dLbls>
+          <c:cat>
+            <c:strRef>
+              <c:f>'2026'!$P$50:$P$58</c:f>
+              <c:strCache>
+                <c:ptCount val="9"/>
+                <c:pt idx="0">
+                  <c:v>ס.פארם</c:v>
+                </c:pt>
+                <c:pt idx="1">
+                  <c:v>אתר </c:v>
+                </c:pt>
+                <c:pt idx="2">
+                  <c:v>קופות</c:v>
+                </c:pt>
+                <c:pt idx="3">
+                  <c:v>מפיצים </c:v>
+                </c:pt>
+                <c:pt idx="4">
+                  <c:v>אמזון </c:v>
+                </c:pt>
+                <c:pt idx="5">
+                  <c:v>בתי מרקחת</c:v>
+                </c:pt>
+                <c:pt idx="6">
+                  <c:v>מכונים</c:v>
+                </c:pt>
+                <c:pt idx="7">
+                  <c:v>BE</c:v>
+                </c:pt>
+                <c:pt idx="8">
+                  <c:v>אחרים </c:v>
+                </c:pt>
+              </c:strCache>
+            </c:strRef>
+          </c:cat>
+          <c:val>
+            <c:numRef>
+              <c:f>'2026'!$Q$50:$Q$58</c:f>
+              <c:numCache>
+                <c:formatCode>0%</c:formatCode>
+                <c:ptCount val="9"/>
+                <c:pt idx="0">
+                  <c:v>0.28889797959581626</c:v>
+                </c:pt>
+                <c:pt idx="1">
+                  <c:v>0.19072350419474854</c:v>
+                </c:pt>
+                <c:pt idx="2">
+                  <c:v>0.15791549370270344</c:v>
+                </c:pt>
+                <c:pt idx="3">
+                  <c:v>0.10982113660021957</c:v>
+                </c:pt>
+                <c:pt idx="4">
+                  <c:v>9.7027520387894292E-2</c:v>
+                </c:pt>
+                <c:pt idx="5">
+                  <c:v>7.0896533809474291E-2</c:v>
+                </c:pt>
+                <c:pt idx="6">
+                  <c:v>4.1106631992353412E-2</c:v>
+                </c:pt>
+                <c:pt idx="7">
+                  <c:v>3.5158290842720485E-2</c:v>
+                </c:pt>
+                <c:pt idx="8">
+                  <c:v>8.4529088740696295E-3</c:v>
+                </c:pt>
+              </c:numCache>
+            </c:numRef>
+          </c:val>
+          <c:extLst>
+            <c:ext xmlns:c16="http://schemas.microsoft.com/office/drawing/2014/chart" uri="{C3380CC4-5D6E-409C-BE32-E72D297353CC}">
+              <c16:uniqueId val="{00000000-1031-448D-A72E-6B1B4152A565}"/>
+            </c:ext>
+          </c:extLst>
+        </c:ser>
+        <c:dLbls>
+          <c:showLegendKey val="0"/>
+          <c:showVal val="0"/>
+          <c:showCatName val="0"/>
+          <c:showSerName val="0"/>
+          <c:showPercent val="0"/>
+          <c:showBubbleSize val="0"/>
+          <c:showLeaderLines val="1"/>
+        </c:dLbls>
+      </c:pie3DChart>
+      <c:spPr>
+        <a:noFill/>
+        <a:ln>
+          <a:noFill/>
+        </a:ln>
+        <a:effectLst/>
+      </c:spPr>
+    </c:plotArea>
+    <c:legend>
+      <c:legendPos val="b"/>
+      <c:overlay val="1"/>
+      <c:spPr>
+        <a:noFill/>
+        <a:ln>
+          <a:noFill/>
+        </a:ln>
+        <a:effectLst/>
+      </c:spPr>
+      <c:txPr>
+        <a:bodyPr rot="0" spcFirstLastPara="1" vertOverflow="ellipsis" vert="horz" wrap="square" anchor="ctr" anchorCtr="1"/>
+        <a:lstStyle/>
+        <a:p>
+          <a:pPr>
+            <a:defRPr sz="900" b="0" i="0" u="none" strike="noStrike" kern="1200" baseline="0">
+              <a:ln>
+                <a:noFill/>
+              </a:ln>
+              <a:solidFill>
+                <a:schemeClr val="tx1">
+                  <a:lumMod val="65000"/>
+                  <a:lumOff val="35000"/>
+                </a:schemeClr>
+              </a:solidFill>
+              <a:latin typeface="+mn-lt"/>
+              <a:ea typeface="+mn-ea"/>
+              <a:cs typeface="+mn-cs"/>
+            </a:defRPr>
+          </a:pPr>
+          <a:endParaRPr lang="he-IL"/>
+        </a:p>
+      </c:txPr>
+    </c:legend>
     <c:plotVisOnly val="1"/>
     <c:dispBlanksAs val="gap"/>
     <c:showDLblsOverMax val="0"/>
@@ -1019,6 +1559,12 @@
     <a:lumMod val="50000"/>
     <a:lumOff val="50000"/>
   </cs:variation>
+</cs:colorStyle>
+</file>
+
+<file path=ppt/charts/colors3.xml><?xml version="1.0" encoding="utf-8"?>
+<cs:colorStyle xmlns:cs="http://schemas.microsoft.com/office/drawing/2012/chartStyle" xmlns:a="http://schemas.openxmlformats.org/drawingml/2006/main" meth="withinLinear" id="14">
+  <a:schemeClr val="accent1"/>
 </cs:colorStyle>
 </file>
 
@@ -1996,6 +2542,525 @@
             <a:lumOff val="85000"/>
           </a:schemeClr>
         </a:solidFill>
+      </a:ln>
+    </cs:spPr>
+  </cs:upBar>
+  <cs:valueAxis>
+    <cs:lnRef idx="0"/>
+    <cs:fillRef idx="0"/>
+    <cs:effectRef idx="0"/>
+    <cs:fontRef idx="minor">
+      <a:schemeClr val="tx1">
+        <a:lumMod val="65000"/>
+        <a:lumOff val="35000"/>
+      </a:schemeClr>
+    </cs:fontRef>
+    <cs:defRPr sz="900" kern="1200"/>
+  </cs:valueAxis>
+  <cs:wall>
+    <cs:lnRef idx="0"/>
+    <cs:fillRef idx="0"/>
+    <cs:effectRef idx="0"/>
+    <cs:fontRef idx="minor">
+      <a:schemeClr val="tx1"/>
+    </cs:fontRef>
+    <cs:spPr>
+      <a:noFill/>
+      <a:ln>
+        <a:noFill/>
+      </a:ln>
+    </cs:spPr>
+  </cs:wall>
+</cs:chartStyle>
+</file>
+
+<file path=ppt/charts/style3.xml><?xml version="1.0" encoding="utf-8"?>
+<cs:chartStyle xmlns:cs="http://schemas.microsoft.com/office/drawing/2012/chartStyle" xmlns:a="http://schemas.openxmlformats.org/drawingml/2006/main" id="262">
+  <cs:axisTitle>
+    <cs:lnRef idx="0"/>
+    <cs:fillRef idx="0"/>
+    <cs:effectRef idx="0"/>
+    <cs:fontRef idx="minor">
+      <a:schemeClr val="tx1">
+        <a:lumMod val="65000"/>
+        <a:lumOff val="35000"/>
+      </a:schemeClr>
+    </cs:fontRef>
+    <cs:defRPr sz="1000" kern="1200"/>
+  </cs:axisTitle>
+  <cs:categoryAxis>
+    <cs:lnRef idx="0"/>
+    <cs:fillRef idx="0"/>
+    <cs:effectRef idx="0"/>
+    <cs:fontRef idx="minor">
+      <a:schemeClr val="tx1">
+        <a:lumMod val="65000"/>
+        <a:lumOff val="35000"/>
+      </a:schemeClr>
+    </cs:fontRef>
+    <cs:spPr>
+      <a:ln w="9525" cap="flat" cmpd="sng" algn="ctr">
+        <a:solidFill>
+          <a:schemeClr val="tx1">
+            <a:lumMod val="15000"/>
+            <a:lumOff val="85000"/>
+          </a:schemeClr>
+        </a:solidFill>
+        <a:round/>
+      </a:ln>
+    </cs:spPr>
+    <cs:defRPr sz="900" kern="1200"/>
+  </cs:categoryAxis>
+  <cs:chartArea mods="allowNoFillOverride allowNoLineOverride">
+    <cs:lnRef idx="0"/>
+    <cs:fillRef idx="0"/>
+    <cs:effectRef idx="0"/>
+    <cs:fontRef idx="minor">
+      <a:schemeClr val="tx1"/>
+    </cs:fontRef>
+    <cs:spPr>
+      <a:solidFill>
+        <a:schemeClr val="bg1"/>
+      </a:solidFill>
+      <a:ln w="9525" cap="flat" cmpd="sng" algn="ctr">
+        <a:solidFill>
+          <a:schemeClr val="tx1">
+            <a:lumMod val="15000"/>
+            <a:lumOff val="85000"/>
+          </a:schemeClr>
+        </a:solidFill>
+        <a:round/>
+      </a:ln>
+    </cs:spPr>
+    <cs:defRPr sz="900" kern="1200"/>
+  </cs:chartArea>
+  <cs:dataLabel>
+    <cs:lnRef idx="0"/>
+    <cs:fillRef idx="0"/>
+    <cs:effectRef idx="0"/>
+    <cs:fontRef idx="minor">
+      <a:schemeClr val="tx1">
+        <a:lumMod val="75000"/>
+        <a:lumOff val="25000"/>
+      </a:schemeClr>
+    </cs:fontRef>
+    <cs:defRPr sz="900" kern="1200"/>
+  </cs:dataLabel>
+  <cs:dataLabelCallout>
+    <cs:lnRef idx="0"/>
+    <cs:fillRef idx="0"/>
+    <cs:effectRef idx="0"/>
+    <cs:fontRef idx="minor">
+      <a:schemeClr val="dk1">
+        <a:lumMod val="65000"/>
+        <a:lumOff val="35000"/>
+      </a:schemeClr>
+    </cs:fontRef>
+    <cs:spPr>
+      <a:solidFill>
+        <a:schemeClr val="lt1"/>
+      </a:solidFill>
+      <a:ln>
+        <a:solidFill>
+          <a:schemeClr val="dk1">
+            <a:lumMod val="25000"/>
+            <a:lumOff val="75000"/>
+          </a:schemeClr>
+        </a:solidFill>
+      </a:ln>
+    </cs:spPr>
+    <cs:defRPr sz="900" kern="1200"/>
+    <cs:bodyPr rot="0" spcFirstLastPara="1" vertOverflow="clip" horzOverflow="clip" vert="horz" wrap="square" lIns="36576" tIns="18288" rIns="36576" bIns="18288" anchor="ctr" anchorCtr="1">
+      <a:spAutoFit/>
+    </cs:bodyPr>
+  </cs:dataLabelCallout>
+  <cs:dataPoint>
+    <cs:lnRef idx="0"/>
+    <cs:fillRef idx="1">
+      <cs:styleClr val="auto"/>
+    </cs:fillRef>
+    <cs:effectRef idx="0"/>
+    <cs:fontRef idx="minor">
+      <a:schemeClr val="tx1"/>
+    </cs:fontRef>
+    <cs:spPr>
+      <a:ln w="19050">
+        <a:solidFill>
+          <a:schemeClr val="lt1"/>
+        </a:solidFill>
+      </a:ln>
+    </cs:spPr>
+  </cs:dataPoint>
+  <cs:dataPoint3D>
+    <cs:lnRef idx="0"/>
+    <cs:fillRef idx="1">
+      <cs:styleClr val="auto"/>
+    </cs:fillRef>
+    <cs:effectRef idx="0"/>
+    <cs:fontRef idx="minor">
+      <a:schemeClr val="tx1"/>
+    </cs:fontRef>
+    <cs:spPr>
+      <a:ln w="25400">
+        <a:solidFill>
+          <a:schemeClr val="lt1"/>
+        </a:solidFill>
+      </a:ln>
+    </cs:spPr>
+  </cs:dataPoint3D>
+  <cs:dataPointLine>
+    <cs:lnRef idx="0">
+      <cs:styleClr val="auto"/>
+    </cs:lnRef>
+    <cs:fillRef idx="0"/>
+    <cs:effectRef idx="0"/>
+    <cs:fontRef idx="minor">
+      <a:schemeClr val="tx1"/>
+    </cs:fontRef>
+    <cs:spPr>
+      <a:ln w="28575" cap="rnd">
+        <a:solidFill>
+          <a:schemeClr val="phClr"/>
+        </a:solidFill>
+        <a:round/>
+      </a:ln>
+    </cs:spPr>
+  </cs:dataPointLine>
+  <cs:dataPointMarker>
+    <cs:lnRef idx="0">
+      <cs:styleClr val="auto"/>
+    </cs:lnRef>
+    <cs:fillRef idx="1">
+      <cs:styleClr val="auto"/>
+    </cs:fillRef>
+    <cs:effectRef idx="0"/>
+    <cs:fontRef idx="minor">
+      <a:schemeClr val="tx1"/>
+    </cs:fontRef>
+    <cs:spPr>
+      <a:ln w="9525">
+        <a:solidFill>
+          <a:schemeClr val="phClr"/>
+        </a:solidFill>
+      </a:ln>
+    </cs:spPr>
+  </cs:dataPointMarker>
+  <cs:dataPointMarkerLayout symbol="circle" size="5"/>
+  <cs:dataPointWireframe>
+    <cs:lnRef idx="0">
+      <cs:styleClr val="auto"/>
+    </cs:lnRef>
+    <cs:fillRef idx="0"/>
+    <cs:effectRef idx="0"/>
+    <cs:fontRef idx="minor">
+      <a:schemeClr val="tx1"/>
+    </cs:fontRef>
+    <cs:spPr>
+      <a:ln w="9525" cap="rnd">
+        <a:solidFill>
+          <a:schemeClr val="phClr"/>
+        </a:solidFill>
+        <a:round/>
+      </a:ln>
+    </cs:spPr>
+  </cs:dataPointWireframe>
+  <cs:dataTable>
+    <cs:lnRef idx="0"/>
+    <cs:fillRef idx="0"/>
+    <cs:effectRef idx="0"/>
+    <cs:fontRef idx="minor">
+      <a:schemeClr val="tx1">
+        <a:lumMod val="65000"/>
+        <a:lumOff val="35000"/>
+      </a:schemeClr>
+    </cs:fontRef>
+    <cs:spPr>
+      <a:noFill/>
+      <a:ln w="9525" cap="flat" cmpd="sng" algn="ctr">
+        <a:solidFill>
+          <a:schemeClr val="tx1">
+            <a:lumMod val="15000"/>
+            <a:lumOff val="85000"/>
+          </a:schemeClr>
+        </a:solidFill>
+        <a:round/>
+      </a:ln>
+    </cs:spPr>
+    <cs:defRPr sz="900" kern="1200"/>
+  </cs:dataTable>
+  <cs:downBar>
+    <cs:lnRef idx="0"/>
+    <cs:fillRef idx="0"/>
+    <cs:effectRef idx="0"/>
+    <cs:fontRef idx="minor">
+      <a:schemeClr val="tx1"/>
+    </cs:fontRef>
+    <cs:spPr>
+      <a:solidFill>
+        <a:schemeClr val="dk1">
+          <a:lumMod val="75000"/>
+          <a:lumOff val="25000"/>
+        </a:schemeClr>
+      </a:solidFill>
+      <a:ln w="9525" cap="flat" cmpd="sng" algn="ctr">
+        <a:solidFill>
+          <a:schemeClr val="tx1">
+            <a:lumMod val="65000"/>
+            <a:lumOff val="35000"/>
+          </a:schemeClr>
+        </a:solidFill>
+        <a:round/>
+      </a:ln>
+    </cs:spPr>
+  </cs:downBar>
+  <cs:dropLine>
+    <cs:lnRef idx="0"/>
+    <cs:fillRef idx="0"/>
+    <cs:effectRef idx="0"/>
+    <cs:fontRef idx="minor">
+      <a:schemeClr val="tx1"/>
+    </cs:fontRef>
+    <cs:spPr>
+      <a:ln w="9525" cap="flat" cmpd="sng" algn="ctr">
+        <a:solidFill>
+          <a:schemeClr val="tx1">
+            <a:lumMod val="35000"/>
+            <a:lumOff val="65000"/>
+          </a:schemeClr>
+        </a:solidFill>
+        <a:round/>
+      </a:ln>
+    </cs:spPr>
+  </cs:dropLine>
+  <cs:errorBar>
+    <cs:lnRef idx="0"/>
+    <cs:fillRef idx="0"/>
+    <cs:effectRef idx="0"/>
+    <cs:fontRef idx="minor">
+      <a:schemeClr val="tx1"/>
+    </cs:fontRef>
+    <cs:spPr>
+      <a:ln w="9525" cap="flat" cmpd="sng" algn="ctr">
+        <a:solidFill>
+          <a:schemeClr val="tx1">
+            <a:lumMod val="65000"/>
+            <a:lumOff val="35000"/>
+          </a:schemeClr>
+        </a:solidFill>
+        <a:round/>
+      </a:ln>
+    </cs:spPr>
+  </cs:errorBar>
+  <cs:floor>
+    <cs:lnRef idx="0"/>
+    <cs:fillRef idx="0"/>
+    <cs:effectRef idx="0"/>
+    <cs:fontRef idx="minor">
+      <a:schemeClr val="tx1"/>
+    </cs:fontRef>
+    <cs:spPr>
+      <a:noFill/>
+      <a:ln>
+        <a:noFill/>
+      </a:ln>
+    </cs:spPr>
+  </cs:floor>
+  <cs:gridlineMajor>
+    <cs:lnRef idx="0"/>
+    <cs:fillRef idx="0"/>
+    <cs:effectRef idx="0"/>
+    <cs:fontRef idx="minor">
+      <a:schemeClr val="tx1"/>
+    </cs:fontRef>
+    <cs:spPr>
+      <a:ln w="9525" cap="flat" cmpd="sng" algn="ctr">
+        <a:solidFill>
+          <a:schemeClr val="tx1">
+            <a:lumMod val="15000"/>
+            <a:lumOff val="85000"/>
+          </a:schemeClr>
+        </a:solidFill>
+        <a:round/>
+      </a:ln>
+    </cs:spPr>
+  </cs:gridlineMajor>
+  <cs:gridlineMinor>
+    <cs:lnRef idx="0"/>
+    <cs:fillRef idx="0"/>
+    <cs:effectRef idx="0"/>
+    <cs:fontRef idx="minor">
+      <a:schemeClr val="tx1"/>
+    </cs:fontRef>
+    <cs:spPr>
+      <a:ln w="9525" cap="flat" cmpd="sng" algn="ctr">
+        <a:solidFill>
+          <a:schemeClr val="tx1">
+            <a:lumMod val="5000"/>
+            <a:lumOff val="95000"/>
+          </a:schemeClr>
+        </a:solidFill>
+        <a:round/>
+      </a:ln>
+    </cs:spPr>
+  </cs:gridlineMinor>
+  <cs:hiLoLine>
+    <cs:lnRef idx="0"/>
+    <cs:fillRef idx="0"/>
+    <cs:effectRef idx="0"/>
+    <cs:fontRef idx="minor">
+      <a:schemeClr val="tx1"/>
+    </cs:fontRef>
+    <cs:spPr>
+      <a:ln w="9525" cap="flat" cmpd="sng" algn="ctr">
+        <a:solidFill>
+          <a:schemeClr val="tx1">
+            <a:lumMod val="50000"/>
+            <a:lumOff val="50000"/>
+          </a:schemeClr>
+        </a:solidFill>
+        <a:round/>
+      </a:ln>
+    </cs:spPr>
+  </cs:hiLoLine>
+  <cs:leaderLine>
+    <cs:lnRef idx="0"/>
+    <cs:fillRef idx="0"/>
+    <cs:effectRef idx="0"/>
+    <cs:fontRef idx="minor">
+      <a:schemeClr val="tx1"/>
+    </cs:fontRef>
+    <cs:spPr>
+      <a:ln w="9525" cap="flat" cmpd="sng" algn="ctr">
+        <a:solidFill>
+          <a:schemeClr val="tx1">
+            <a:lumMod val="35000"/>
+            <a:lumOff val="65000"/>
+          </a:schemeClr>
+        </a:solidFill>
+        <a:round/>
+      </a:ln>
+    </cs:spPr>
+  </cs:leaderLine>
+  <cs:legend>
+    <cs:lnRef idx="0"/>
+    <cs:fillRef idx="0"/>
+    <cs:effectRef idx="0"/>
+    <cs:fontRef idx="minor">
+      <a:schemeClr val="tx1">
+        <a:lumMod val="65000"/>
+        <a:lumOff val="35000"/>
+      </a:schemeClr>
+    </cs:fontRef>
+    <cs:defRPr sz="900" kern="1200"/>
+  </cs:legend>
+  <cs:plotArea mods="allowNoFillOverride allowNoLineOverride">
+    <cs:lnRef idx="0"/>
+    <cs:fillRef idx="0"/>
+    <cs:effectRef idx="0"/>
+    <cs:fontRef idx="minor">
+      <a:schemeClr val="tx1"/>
+    </cs:fontRef>
+  </cs:plotArea>
+  <cs:plotArea3D mods="allowNoFillOverride allowNoLineOverride">
+    <cs:lnRef idx="0"/>
+    <cs:fillRef idx="0"/>
+    <cs:effectRef idx="0"/>
+    <cs:fontRef idx="minor">
+      <a:schemeClr val="tx1"/>
+    </cs:fontRef>
+  </cs:plotArea3D>
+  <cs:seriesAxis>
+    <cs:lnRef idx="0"/>
+    <cs:fillRef idx="0"/>
+    <cs:effectRef idx="0"/>
+    <cs:fontRef idx="minor">
+      <a:schemeClr val="tx1">
+        <a:lumMod val="65000"/>
+        <a:lumOff val="35000"/>
+      </a:schemeClr>
+    </cs:fontRef>
+    <cs:defRPr sz="900" kern="1200"/>
+  </cs:seriesAxis>
+  <cs:seriesLine>
+    <cs:lnRef idx="0"/>
+    <cs:fillRef idx="0"/>
+    <cs:effectRef idx="0"/>
+    <cs:fontRef idx="minor">
+      <a:schemeClr val="tx1"/>
+    </cs:fontRef>
+    <cs:spPr>
+      <a:ln w="9525" cap="flat" cmpd="sng" algn="ctr">
+        <a:solidFill>
+          <a:schemeClr val="tx1">
+            <a:lumMod val="35000"/>
+            <a:lumOff val="65000"/>
+          </a:schemeClr>
+        </a:solidFill>
+        <a:round/>
+      </a:ln>
+    </cs:spPr>
+  </cs:seriesLine>
+  <cs:title>
+    <cs:lnRef idx="0"/>
+    <cs:fillRef idx="0"/>
+    <cs:effectRef idx="0"/>
+    <cs:fontRef idx="minor">
+      <a:schemeClr val="tx1">
+        <a:lumMod val="65000"/>
+        <a:lumOff val="35000"/>
+      </a:schemeClr>
+    </cs:fontRef>
+    <cs:defRPr sz="1400" b="0" kern="1200" spc="0" baseline="0"/>
+  </cs:title>
+  <cs:trendline>
+    <cs:lnRef idx="0">
+      <cs:styleClr val="auto"/>
+    </cs:lnRef>
+    <cs:fillRef idx="0"/>
+    <cs:effectRef idx="0"/>
+    <cs:fontRef idx="minor">
+      <a:schemeClr val="tx1"/>
+    </cs:fontRef>
+    <cs:spPr>
+      <a:ln w="19050" cap="rnd">
+        <a:solidFill>
+          <a:schemeClr val="phClr"/>
+        </a:solidFill>
+        <a:prstDash val="sysDot"/>
+      </a:ln>
+    </cs:spPr>
+  </cs:trendline>
+  <cs:trendlineLabel>
+    <cs:lnRef idx="0"/>
+    <cs:fillRef idx="0"/>
+    <cs:effectRef idx="0"/>
+    <cs:fontRef idx="minor">
+      <a:schemeClr val="tx1">
+        <a:lumMod val="65000"/>
+        <a:lumOff val="35000"/>
+      </a:schemeClr>
+    </cs:fontRef>
+    <cs:defRPr sz="900" kern="1200"/>
+  </cs:trendlineLabel>
+  <cs:upBar>
+    <cs:lnRef idx="0"/>
+    <cs:fillRef idx="0"/>
+    <cs:effectRef idx="0"/>
+    <cs:fontRef idx="minor">
+      <a:schemeClr val="tx1"/>
+    </cs:fontRef>
+    <cs:spPr>
+      <a:solidFill>
+        <a:schemeClr val="lt1"/>
+      </a:solidFill>
+      <a:ln w="9525" cap="flat" cmpd="sng" algn="ctr">
+        <a:solidFill>
+          <a:schemeClr val="tx1">
+            <a:lumMod val="65000"/>
+            <a:lumOff val="35000"/>
+          </a:schemeClr>
+        </a:solidFill>
+        <a:round/>
       </a:ln>
     </cs:spPr>
   </cs:upBar>
@@ -3680,7 +4745,7 @@
           <p:nvPr>
             <p:extLst>
               <p:ext uri="{D42A27DB-BD31-4B8C-83A1-F6EECF244321}">
-                <p14:modId xmlns:p14="http://schemas.microsoft.com/office/powerpoint/2010/main" val="262666735"/>
+                <p14:modId xmlns:p14="http://schemas.microsoft.com/office/powerpoint/2010/main" val="3013134382"/>
               </p:ext>
             </p:extLst>
           </p:nvPr>
@@ -4257,21 +5322,21 @@
           <p:nvPr>
             <p:extLst>
               <p:ext uri="{D42A27DB-BD31-4B8C-83A1-F6EECF244321}">
-                <p14:modId xmlns:p14="http://schemas.microsoft.com/office/powerpoint/2010/main" val="2563751525"/>
+                <p14:modId xmlns:p14="http://schemas.microsoft.com/office/powerpoint/2010/main" val="3759684657"/>
               </p:ext>
             </p:extLst>
           </p:nvPr>
         </p:nvGraphicFramePr>
         <p:xfrm>
-          <a:off x="7500000" y="1434017"/>
-          <a:ext cx="4200000" cy="2543175"/>
+          <a:off x="7352715" y="1708337"/>
+          <a:ext cx="3756264" cy="2543175"/>
         </p:xfrm>
         <a:graphic>
           <a:graphicData uri="http://schemas.openxmlformats.org/drawingml/2006/table">
             <a:tbl>
               <a:tblPr rtl="1"/>
               <a:tblGrid>
-                <a:gridCol w="1600200">
+                <a:gridCol w="1156464">
                   <a:extLst>
                     <a:ext uri="{9D8B030D-6E8A-4147-A177-3AD203B41FA5}">
                       <a16:colId xmlns:a16="http://schemas.microsoft.com/office/drawing/2014/main" val="2423334984"/>
@@ -4496,7 +5561,7 @@
                         <a:buNone/>
                       </a:pPr>
                       <a:r>
-                        <a:rPr lang="he-IL" sz="1000" b="1" i="0" u="none" strike="noStrike">
+                        <a:rPr lang="he-IL" sz="1000" b="1" i="0" u="none" strike="noStrike" dirty="0">
                           <a:solidFill>
                             <a:srgbClr val="FFFFFF"/>
                           </a:solidFill>
@@ -4604,7 +5669,7 @@
                     </a:lnR>
                     <a:lnT w="6350" cap="flat" cmpd="sng" algn="ctr">
                       <a:solidFill>
-                        <a:srgbClr val="D9D9D9"/>
+                        <a:srgbClr val="002F6C"/>
                       </a:solidFill>
                       <a:prstDash val="solid"/>
                       <a:round/>
@@ -4628,7 +5693,7 @@
                     <a:bodyPr/>
                     <a:lstStyle/>
                     <a:p>
-                      <a:pPr algn="ctr" rtl="0" fontAlgn="b">
+                      <a:pPr algn="r" rtl="0" fontAlgn="b">
                         <a:buNone/>
                       </a:pPr>
                       <a:r>
@@ -4664,7 +5729,7 @@
                     </a:lnR>
                     <a:lnT w="6350" cap="flat" cmpd="sng" algn="ctr">
                       <a:solidFill>
-                        <a:srgbClr val="D9D9D9"/>
+                        <a:srgbClr val="002F6C"/>
                       </a:solidFill>
                       <a:prstDash val="solid"/>
                       <a:round/>
@@ -4688,7 +5753,7 @@
                     <a:bodyPr/>
                     <a:lstStyle/>
                     <a:p>
-                      <a:pPr algn="ctr" rtl="0" fontAlgn="b">
+                      <a:pPr algn="r" rtl="0" fontAlgn="b">
                         <a:buNone/>
                       </a:pPr>
                       <a:r>
@@ -4724,7 +5789,7 @@
                     </a:lnR>
                     <a:lnT w="6350" cap="flat" cmpd="sng" algn="ctr">
                       <a:solidFill>
-                        <a:srgbClr val="D9D9D9"/>
+                        <a:srgbClr val="002F6C"/>
                       </a:solidFill>
                       <a:prstDash val="solid"/>
                       <a:round/>
@@ -4784,7 +5849,7 @@
                     </a:lnR>
                     <a:lnT w="6350" cap="flat" cmpd="sng" algn="ctr">
                       <a:solidFill>
-                        <a:srgbClr val="D9D9D9"/>
+                        <a:srgbClr val="002F6C"/>
                       </a:solidFill>
                       <a:prstDash val="solid"/>
                       <a:round/>
@@ -4875,7 +5940,7 @@
                     <a:bodyPr/>
                     <a:lstStyle/>
                     <a:p>
-                      <a:pPr algn="ctr" rtl="0" fontAlgn="b">
+                      <a:pPr algn="r" rtl="0" fontAlgn="b">
                         <a:buNone/>
                       </a:pPr>
                       <a:r>
@@ -4935,7 +6000,7 @@
                     <a:bodyPr/>
                     <a:lstStyle/>
                     <a:p>
-                      <a:pPr algn="ctr" rtl="0" fontAlgn="b">
+                      <a:pPr algn="r" rtl="0" fontAlgn="b">
                         <a:buNone/>
                       </a:pPr>
                       <a:r>
@@ -5122,7 +6187,7 @@
                     <a:bodyPr/>
                     <a:lstStyle/>
                     <a:p>
-                      <a:pPr algn="ctr" rtl="0" fontAlgn="b">
+                      <a:pPr algn="r" rtl="0" fontAlgn="b">
                         <a:buNone/>
                       </a:pPr>
                       <a:r>
@@ -5182,7 +6247,7 @@
                     <a:bodyPr/>
                     <a:lstStyle/>
                     <a:p>
-                      <a:pPr algn="ctr" rtl="0" fontAlgn="b">
+                      <a:pPr algn="r" rtl="0" fontAlgn="b">
                         <a:buNone/>
                       </a:pPr>
                       <a:r>
@@ -5369,7 +6434,7 @@
                     <a:bodyPr/>
                     <a:lstStyle/>
                     <a:p>
-                      <a:pPr algn="ctr" rtl="0" fontAlgn="b">
+                      <a:pPr algn="r" rtl="0" fontAlgn="b">
                         <a:buNone/>
                       </a:pPr>
                       <a:r>
@@ -5429,7 +6494,7 @@
                     <a:bodyPr/>
                     <a:lstStyle/>
                     <a:p>
-                      <a:pPr algn="ctr" rtl="0" fontAlgn="b">
+                      <a:pPr algn="r" rtl="0" fontAlgn="b">
                         <a:buNone/>
                       </a:pPr>
                       <a:r>
@@ -5616,7 +6681,7 @@
                     <a:bodyPr/>
                     <a:lstStyle/>
                     <a:p>
-                      <a:pPr algn="ctr" rtl="0" fontAlgn="b">
+                      <a:pPr algn="r" rtl="0" fontAlgn="b">
                         <a:buNone/>
                       </a:pPr>
                       <a:r>
@@ -5676,7 +6741,7 @@
                     <a:bodyPr/>
                     <a:lstStyle/>
                     <a:p>
-                      <a:pPr algn="ctr" rtl="0" fontAlgn="b">
+                      <a:pPr algn="r" rtl="0" fontAlgn="b">
                         <a:buNone/>
                       </a:pPr>
                       <a:r>
@@ -5863,7 +6928,7 @@
                     <a:bodyPr/>
                     <a:lstStyle/>
                     <a:p>
-                      <a:pPr algn="ctr" rtl="0" fontAlgn="b">
+                      <a:pPr algn="r" rtl="0" fontAlgn="b">
                         <a:buNone/>
                       </a:pPr>
                       <a:r>
@@ -5923,11 +6988,11 @@
                     <a:bodyPr/>
                     <a:lstStyle/>
                     <a:p>
-                      <a:pPr algn="ctr" rtl="0" fontAlgn="b">
+                      <a:pPr algn="r" rtl="0" fontAlgn="b">
                         <a:buNone/>
                       </a:pPr>
                       <a:r>
-                        <a:rPr lang="he-IL" sz="1000" b="0" i="0" u="none" strike="noStrike">
+                        <a:rPr lang="he-IL" sz="1000" b="0" i="0" u="none" strike="noStrike" dirty="0">
                           <a:solidFill>
                             <a:srgbClr val="000000"/>
                           </a:solidFill>
@@ -6110,7 +7175,7 @@
                     <a:bodyPr/>
                     <a:lstStyle/>
                     <a:p>
-                      <a:pPr algn="ctr" rtl="0" fontAlgn="b">
+                      <a:pPr algn="r" rtl="0" fontAlgn="b">
                         <a:buNone/>
                       </a:pPr>
                       <a:r>
@@ -6170,11 +7235,11 @@
                     <a:bodyPr/>
                     <a:lstStyle/>
                     <a:p>
-                      <a:pPr algn="ctr" rtl="0" fontAlgn="b">
+                      <a:pPr algn="r" rtl="0" fontAlgn="b">
                         <a:buNone/>
                       </a:pPr>
                       <a:r>
-                        <a:rPr lang="he-IL" sz="1000" b="0" i="0" u="none" strike="noStrike">
+                        <a:rPr lang="he-IL" sz="1000" b="0" i="0" u="none" strike="noStrike" dirty="0">
                           <a:solidFill>
                             <a:srgbClr val="000000"/>
                           </a:solidFill>
@@ -6357,7 +7422,7 @@
                     <a:bodyPr/>
                     <a:lstStyle/>
                     <a:p>
-                      <a:pPr algn="ctr" rtl="0" fontAlgn="b">
+                      <a:pPr algn="r" rtl="0" fontAlgn="b">
                         <a:buNone/>
                       </a:pPr>
                       <a:r>
@@ -6417,11 +7482,11 @@
                     <a:bodyPr/>
                     <a:lstStyle/>
                     <a:p>
-                      <a:pPr algn="ctr" rtl="0" fontAlgn="b">
+                      <a:pPr algn="r" rtl="0" fontAlgn="b">
                         <a:buNone/>
                       </a:pPr>
                       <a:r>
-                        <a:rPr lang="he-IL" sz="1000" b="0" i="0" u="none" strike="noStrike">
+                        <a:rPr lang="he-IL" sz="1000" b="0" i="0" u="none" strike="noStrike" dirty="0">
                           <a:solidFill>
                             <a:srgbClr val="000000"/>
                           </a:solidFill>
@@ -6604,7 +7669,7 @@
                     <a:bodyPr/>
                     <a:lstStyle/>
                     <a:p>
-                      <a:pPr algn="ctr" rtl="0" fontAlgn="b">
+                      <a:pPr algn="r" rtl="0" fontAlgn="b">
                         <a:buNone/>
                       </a:pPr>
                       <a:r>
@@ -6664,11 +7729,11 @@
                     <a:bodyPr/>
                     <a:lstStyle/>
                     <a:p>
-                      <a:pPr algn="ctr" rtl="0" fontAlgn="b">
+                      <a:pPr algn="r" rtl="0" fontAlgn="b">
                         <a:buNone/>
                       </a:pPr>
                       <a:r>
-                        <a:rPr lang="he-IL" sz="1000" b="0" i="0" u="none" strike="noStrike">
+                        <a:rPr lang="he-IL" sz="1000" b="0" i="0" u="none" strike="noStrike" dirty="0">
                           <a:solidFill>
                             <a:srgbClr val="000000"/>
                           </a:solidFill>
@@ -6851,7 +7916,7 @@
                     <a:bodyPr/>
                     <a:lstStyle/>
                     <a:p>
-                      <a:pPr algn="ctr" rtl="0" fontAlgn="b">
+                      <a:pPr algn="r" rtl="0" fontAlgn="b">
                         <a:buNone/>
                       </a:pPr>
                       <a:r>
@@ -6911,11 +7976,11 @@
                     <a:bodyPr/>
                     <a:lstStyle/>
                     <a:p>
-                      <a:pPr algn="ctr" rtl="0" fontAlgn="b">
+                      <a:pPr algn="r" rtl="0" fontAlgn="b">
                         <a:buNone/>
                       </a:pPr>
                       <a:r>
-                        <a:rPr lang="he-IL" sz="1000" b="0" i="0" u="none" strike="noStrike">
+                        <a:rPr lang="he-IL" sz="1000" b="0" i="0" u="none" strike="noStrike" dirty="0">
                           <a:solidFill>
                             <a:srgbClr val="000000"/>
                           </a:solidFill>
@@ -7098,7 +8163,7 @@
                     <a:bodyPr/>
                     <a:lstStyle/>
                     <a:p>
-                      <a:pPr algn="ctr" rtl="0" fontAlgn="b">
+                      <a:pPr algn="r" rtl="0" fontAlgn="b">
                         <a:buNone/>
                       </a:pPr>
                       <a:r>
@@ -7158,11 +8223,11 @@
                     <a:bodyPr/>
                     <a:lstStyle/>
                     <a:p>
-                      <a:pPr algn="ctr" rtl="0" fontAlgn="b">
+                      <a:pPr algn="r" rtl="0" fontAlgn="b">
                         <a:buNone/>
                       </a:pPr>
                       <a:r>
-                        <a:rPr lang="he-IL" sz="1000" b="0" i="0" u="none" strike="noStrike">
+                        <a:rPr lang="he-IL" sz="1000" b="0" i="0" u="none" strike="noStrike" dirty="0">
                           <a:solidFill>
                             <a:srgbClr val="000000"/>
                           </a:solidFill>
@@ -7345,7 +8410,7 @@
                     <a:bodyPr/>
                     <a:lstStyle/>
                     <a:p>
-                      <a:pPr algn="ctr" rtl="0" fontAlgn="b">
+                      <a:pPr algn="r" rtl="0" fontAlgn="b">
                         <a:buNone/>
                       </a:pPr>
                       <a:r>
@@ -7405,7 +8470,7 @@
                     <a:bodyPr/>
                     <a:lstStyle/>
                     <a:p>
-                      <a:pPr algn="ctr" rtl="0" fontAlgn="b">
+                      <a:pPr algn="r" rtl="0" fontAlgn="b">
                         <a:buNone/>
                       </a:pPr>
                       <a:r>
@@ -7566,9 +8631,9 @@
                       <a:headEnd type="none" w="med" len="med"/>
                       <a:tailEnd type="none" w="med" len="med"/>
                     </a:lnR>
-                    <a:lnT w="28575" cap="flat" cmpd="sng" algn="ctr">
-                      <a:solidFill>
-                        <a:srgbClr val="002F6C"/>
+                    <a:lnT w="6350" cap="flat" cmpd="sng" algn="ctr">
+                      <a:solidFill>
+                        <a:srgbClr val="D9D9D9"/>
                       </a:solidFill>
                       <a:prstDash val="solid"/>
                       <a:round/>
@@ -7594,7 +8659,7 @@
                     <a:bodyPr/>
                     <a:lstStyle/>
                     <a:p>
-                      <a:pPr algn="ctr" rtl="0" fontAlgn="b">
+                      <a:pPr algn="r" rtl="0" fontAlgn="b">
                         <a:buNone/>
                       </a:pPr>
                       <a:r>
@@ -7628,9 +8693,9 @@
                       <a:headEnd type="none" w="med" len="med"/>
                       <a:tailEnd type="none" w="med" len="med"/>
                     </a:lnR>
-                    <a:lnT w="28575" cap="flat" cmpd="sng" algn="ctr">
-                      <a:solidFill>
-                        <a:srgbClr val="002F6C"/>
+                    <a:lnT w="6350" cap="flat" cmpd="sng" algn="ctr">
+                      <a:solidFill>
+                        <a:srgbClr val="D9D9D9"/>
                       </a:solidFill>
                       <a:prstDash val="solid"/>
                       <a:round/>
@@ -7656,11 +8721,11 @@
                     <a:bodyPr/>
                     <a:lstStyle/>
                     <a:p>
-                      <a:pPr algn="ctr" rtl="0" fontAlgn="b">
+                      <a:pPr algn="r" rtl="0" fontAlgn="b">
                         <a:buNone/>
                       </a:pPr>
                       <a:r>
-                        <a:rPr lang="he-IL" sz="1000" b="1" i="0" u="none" strike="noStrike">
+                        <a:rPr lang="he-IL" sz="1000" b="1" i="0" u="none" strike="noStrike" dirty="0">
                           <a:solidFill>
                             <a:srgbClr val="002F6C"/>
                           </a:solidFill>
@@ -7690,9 +8755,9 @@
                       <a:headEnd type="none" w="med" len="med"/>
                       <a:tailEnd type="none" w="med" len="med"/>
                     </a:lnR>
-                    <a:lnT w="28575" cap="flat" cmpd="sng" algn="ctr">
-                      <a:solidFill>
-                        <a:srgbClr val="002F6C"/>
+                    <a:lnT w="6350" cap="flat" cmpd="sng" algn="ctr">
+                      <a:solidFill>
+                        <a:srgbClr val="D9D9D9"/>
                       </a:solidFill>
                       <a:prstDash val="solid"/>
                       <a:round/>
@@ -7752,9 +8817,9 @@
                       <a:headEnd type="none" w="med" len="med"/>
                       <a:tailEnd type="none" w="med" len="med"/>
                     </a:lnR>
-                    <a:lnT w="28575" cap="flat" cmpd="sng" algn="ctr">
-                      <a:solidFill>
-                        <a:srgbClr val="002F6C"/>
+                    <a:lnT w="6350" cap="flat" cmpd="sng" algn="ctr">
+                      <a:solidFill>
+                        <a:srgbClr val="D9D9D9"/>
                       </a:solidFill>
                       <a:prstDash val="solid"/>
                       <a:round/>
@@ -7800,13 +8865,13 @@
           <p:nvPr>
             <p:extLst>
               <p:ext uri="{D42A27DB-BD31-4B8C-83A1-F6EECF244321}">
-                <p14:modId xmlns:p14="http://schemas.microsoft.com/office/powerpoint/2010/main" val="279694613"/>
+                <p14:modId xmlns:p14="http://schemas.microsoft.com/office/powerpoint/2010/main" val="1711372906"/>
               </p:ext>
             </p:extLst>
           </p:nvPr>
         </p:nvGraphicFramePr>
         <p:xfrm>
-          <a:off x="1943886" y="1434017"/>
+          <a:off x="1349526" y="1708337"/>
           <a:ext cx="4591210" cy="2772014"/>
         </p:xfrm>
         <a:graphic>
@@ -7829,8 +8894,8 @@
         </p:nvSpPr>
         <p:spPr>
           <a:xfrm>
-            <a:off x="4797012" y="4591407"/>
-            <a:ext cx="5810448" cy="548640"/>
+            <a:off x="946842" y="4779786"/>
+            <a:ext cx="3844068" cy="739754"/>
           </a:xfrm>
           <a:prstGeom prst="rect">
             <a:avLst/>
@@ -7838,7 +8903,7 @@
           <a:noFill/>
         </p:spPr>
         <p:txBody>
-          <a:bodyPr wrap="square">
+          <a:bodyPr wrap="square" anchor="ctr">
             <a:spAutoFit/>
           </a:bodyPr>
           <a:lstStyle/>
@@ -7856,7 +8921,7 @@
                 <a:latin typeface="Arial"/>
                 <a:cs typeface="Arial" panose="020B0604020202020204" pitchFamily="34" charset="0"/>
               </a:rPr>
-              <a:t>עמידה ב </a:t>
+              <a:t>צפי עמידה ב </a:t>
             </a:r>
             <a:r>
               <a:rPr lang="he-IL" sz="3200" b="1" kern="0" dirty="0">
@@ -7881,10 +8946,500 @@
           </a:p>
         </p:txBody>
       </p:sp>
+      <p:sp>
+        <p:nvSpPr>
+          <p:cNvPr id="3" name="תיבת טקסט 2">
+            <a:extLst>
+              <a:ext uri="{FF2B5EF4-FFF2-40B4-BE49-F238E27FC236}">
+                <a16:creationId xmlns:a16="http://schemas.microsoft.com/office/drawing/2014/main" id="{15367166-411C-C20C-1329-9F7028A3BBAE}"/>
+              </a:ext>
+            </a:extLst>
+          </p:cNvPr>
+          <p:cNvSpPr txBox="1"/>
+          <p:nvPr/>
+        </p:nvSpPr>
+        <p:spPr>
+          <a:xfrm rot="16200000">
+            <a:off x="4059936" y="2996588"/>
+            <a:ext cx="2093976" cy="276999"/>
+          </a:xfrm>
+          <a:prstGeom prst="rect">
+            <a:avLst/>
+          </a:prstGeom>
+          <a:noFill/>
+        </p:spPr>
+        <p:txBody>
+          <a:bodyPr wrap="square" rtlCol="1">
+            <a:spAutoFit/>
+          </a:bodyPr>
+          <a:lstStyle/>
+          <a:p>
+            <a:pPr algn="ctr"/>
+            <a:r>
+              <a:rPr lang="he-IL" sz="1200" dirty="0"/>
+              <a:t>עודכן ביולי 2026</a:t>
+            </a:r>
+          </a:p>
+        </p:txBody>
+      </p:sp>
+      <p:sp>
+        <p:nvSpPr>
+          <p:cNvPr id="6" name="סוגר מסולסל ימני 5">
+            <a:extLst>
+              <a:ext uri="{FF2B5EF4-FFF2-40B4-BE49-F238E27FC236}">
+                <a16:creationId xmlns:a16="http://schemas.microsoft.com/office/drawing/2014/main" id="{5AA69D9C-61CC-6B04-C284-73EAD2F70250}"/>
+              </a:ext>
+            </a:extLst>
+          </p:cNvPr>
+          <p:cNvSpPr/>
+          <p:nvPr/>
+        </p:nvSpPr>
+        <p:spPr>
+          <a:xfrm rot="5400000">
+            <a:off x="2688943" y="3510479"/>
+            <a:ext cx="373687" cy="2313431"/>
+          </a:xfrm>
+          <a:prstGeom prst="rightBrace">
+            <a:avLst>
+              <a:gd name="adj1" fmla="val 0"/>
+              <a:gd name="adj2" fmla="val 50000"/>
+            </a:avLst>
+          </a:prstGeom>
+        </p:spPr>
+        <p:style>
+          <a:lnRef idx="1">
+            <a:schemeClr val="accent1"/>
+          </a:lnRef>
+          <a:fillRef idx="0">
+            <a:schemeClr val="accent1"/>
+          </a:fillRef>
+          <a:effectRef idx="0">
+            <a:schemeClr val="accent1"/>
+          </a:effectRef>
+          <a:fontRef idx="minor">
+            <a:schemeClr val="tx1"/>
+          </a:fontRef>
+        </p:style>
+        <p:txBody>
+          <a:bodyPr rtlCol="1" anchor="ctr"/>
+          <a:lstStyle/>
+          <a:p>
+            <a:pPr algn="ctr"/>
+            <a:endParaRPr lang="he-IL"/>
+          </a:p>
+        </p:txBody>
+      </p:sp>
     </p:spTree>
     <p:extLst>
       <p:ext uri="{BB962C8B-B14F-4D97-AF65-F5344CB8AC3E}">
         <p14:creationId xmlns:p14="http://schemas.microsoft.com/office/powerpoint/2010/main" val="423875914"/>
+      </p:ext>
+    </p:extLst>
+  </p:cSld>
+  <p:clrMapOvr>
+    <a:masterClrMapping/>
+  </p:clrMapOvr>
+</p:sld>
+</file>
+
+<file path=ppt/slides/slide3.xml><?xml version="1.0" encoding="utf-8"?>
+<p:sld xmlns:a="http://schemas.openxmlformats.org/drawingml/2006/main" xmlns:r="http://schemas.openxmlformats.org/officeDocument/2006/relationships" xmlns:p="http://schemas.openxmlformats.org/presentationml/2006/main">
+  <p:cSld>
+    <p:spTree>
+      <p:nvGrpSpPr>
+        <p:cNvPr id="1" name="">
+          <a:extLst>
+            <a:ext uri="{FF2B5EF4-FFF2-40B4-BE49-F238E27FC236}">
+              <a16:creationId xmlns:a16="http://schemas.microsoft.com/office/drawing/2014/main" id="{F80B3E5B-1A14-C342-25E7-91B773BBE0D8}"/>
+            </a:ext>
+          </a:extLst>
+        </p:cNvPr>
+        <p:cNvGrpSpPr/>
+        <p:nvPr/>
+      </p:nvGrpSpPr>
+      <p:grpSpPr>
+        <a:xfrm>
+          <a:off x="0" y="0"/>
+          <a:ext cx="0" cy="0"/>
+          <a:chOff x="0" y="0"/>
+          <a:chExt cx="0" cy="0"/>
+        </a:xfrm>
+      </p:grpSpPr>
+      <p:pic>
+        <p:nvPicPr>
+          <p:cNvPr id="950" name="FooterLineLogo">
+            <a:extLst>
+              <a:ext uri="{FF2B5EF4-FFF2-40B4-BE49-F238E27FC236}">
+                <a16:creationId xmlns:a16="http://schemas.microsoft.com/office/drawing/2014/main" id="{1E4F773A-F76A-634D-5265-7982AAEA2742}"/>
+              </a:ext>
+            </a:extLst>
+          </p:cNvPr>
+          <p:cNvPicPr>
+            <a:picLocks noChangeAspect="1"/>
+          </p:cNvPicPr>
+          <p:nvPr/>
+        </p:nvPicPr>
+        <p:blipFill>
+          <a:blip r:embed="rId2"/>
+          <a:stretch>
+            <a:fillRect/>
+          </a:stretch>
+        </p:blipFill>
+        <p:spPr>
+          <a:xfrm>
+            <a:off x="0" y="6223001"/>
+            <a:ext cx="12192000" cy="495300"/>
+          </a:xfrm>
+          <a:prstGeom prst="rect">
+            <a:avLst/>
+          </a:prstGeom>
+        </p:spPr>
+      </p:pic>
+      <p:sp>
+        <p:nvSpPr>
+          <p:cNvPr id="5" name="Google Shape;107;g341c3af2acd_1_217">
+            <a:extLst>
+              <a:ext uri="{FF2B5EF4-FFF2-40B4-BE49-F238E27FC236}">
+                <a16:creationId xmlns:a16="http://schemas.microsoft.com/office/drawing/2014/main" id="{D818506A-1019-9170-2F9D-854BC773EEF9}"/>
+              </a:ext>
+            </a:extLst>
+          </p:cNvPr>
+          <p:cNvSpPr txBox="1"/>
+          <p:nvPr/>
+        </p:nvSpPr>
+        <p:spPr>
+          <a:xfrm>
+            <a:off x="3381315" y="384829"/>
+            <a:ext cx="7942800" cy="369332"/>
+          </a:xfrm>
+          <a:prstGeom prst="rect">
+            <a:avLst/>
+          </a:prstGeom>
+          <a:noFill/>
+          <a:ln>
+            <a:noFill/>
+          </a:ln>
+        </p:spPr>
+        <p:txBody>
+          <a:bodyPr spcFirstLastPara="1" wrap="square" lIns="0" tIns="0" rIns="0" bIns="0" anchor="t" anchorCtr="0">
+            <a:spAutoFit/>
+          </a:bodyPr>
+          <a:lstStyle>
+            <a:defPPr marR="0" lvl="0" algn="l" rtl="0">
+              <a:lnSpc>
+                <a:spcPct val="100000"/>
+              </a:lnSpc>
+              <a:spcBef>
+                <a:spcPts val="0"/>
+              </a:spcBef>
+              <a:spcAft>
+                <a:spcPts val="0"/>
+              </a:spcAft>
+            </a:defPPr>
+            <a:lvl1pPr marR="0" lvl="0" algn="l" rtl="0">
+              <a:lnSpc>
+                <a:spcPct val="100000"/>
+              </a:lnSpc>
+              <a:spcBef>
+                <a:spcPts val="0"/>
+              </a:spcBef>
+              <a:spcAft>
+                <a:spcPts val="0"/>
+              </a:spcAft>
+              <a:buClr>
+                <a:srgbClr val="000000"/>
+              </a:buClr>
+              <a:buFont typeface="Arial"/>
+              <a:defRPr sz="1400" b="0" i="0" u="none" strike="noStrike" cap="none">
+                <a:solidFill>
+                  <a:srgbClr val="000000"/>
+                </a:solidFill>
+                <a:latin typeface="Arial"/>
+                <a:ea typeface="Arial"/>
+                <a:cs typeface="Arial"/>
+                <a:sym typeface="Arial"/>
+              </a:defRPr>
+            </a:lvl1pPr>
+            <a:lvl2pPr marR="0" lvl="1" algn="l" rtl="0">
+              <a:lnSpc>
+                <a:spcPct val="100000"/>
+              </a:lnSpc>
+              <a:spcBef>
+                <a:spcPts val="0"/>
+              </a:spcBef>
+              <a:spcAft>
+                <a:spcPts val="0"/>
+              </a:spcAft>
+              <a:buClr>
+                <a:srgbClr val="000000"/>
+              </a:buClr>
+              <a:buFont typeface="Arial"/>
+              <a:defRPr sz="1400" b="0" i="0" u="none" strike="noStrike" cap="none">
+                <a:solidFill>
+                  <a:srgbClr val="000000"/>
+                </a:solidFill>
+                <a:latin typeface="Arial"/>
+                <a:ea typeface="Arial"/>
+                <a:cs typeface="Arial"/>
+                <a:sym typeface="Arial"/>
+              </a:defRPr>
+            </a:lvl2pPr>
+            <a:lvl3pPr marR="0" lvl="2" algn="l" rtl="0">
+              <a:lnSpc>
+                <a:spcPct val="100000"/>
+              </a:lnSpc>
+              <a:spcBef>
+                <a:spcPts val="0"/>
+              </a:spcBef>
+              <a:spcAft>
+                <a:spcPts val="0"/>
+              </a:spcAft>
+              <a:buClr>
+                <a:srgbClr val="000000"/>
+              </a:buClr>
+              <a:buFont typeface="Arial"/>
+              <a:defRPr sz="1400" b="0" i="0" u="none" strike="noStrike" cap="none">
+                <a:solidFill>
+                  <a:srgbClr val="000000"/>
+                </a:solidFill>
+                <a:latin typeface="Arial"/>
+                <a:ea typeface="Arial"/>
+                <a:cs typeface="Arial"/>
+                <a:sym typeface="Arial"/>
+              </a:defRPr>
+            </a:lvl3pPr>
+            <a:lvl4pPr marR="0" lvl="3" algn="l" rtl="0">
+              <a:lnSpc>
+                <a:spcPct val="100000"/>
+              </a:lnSpc>
+              <a:spcBef>
+                <a:spcPts val="0"/>
+              </a:spcBef>
+              <a:spcAft>
+                <a:spcPts val="0"/>
+              </a:spcAft>
+              <a:buClr>
+                <a:srgbClr val="000000"/>
+              </a:buClr>
+              <a:buFont typeface="Arial"/>
+              <a:defRPr sz="1400" b="0" i="0" u="none" strike="noStrike" cap="none">
+                <a:solidFill>
+                  <a:srgbClr val="000000"/>
+                </a:solidFill>
+                <a:latin typeface="Arial"/>
+                <a:ea typeface="Arial"/>
+                <a:cs typeface="Arial"/>
+                <a:sym typeface="Arial"/>
+              </a:defRPr>
+            </a:lvl4pPr>
+            <a:lvl5pPr marR="0" lvl="4" algn="l" rtl="0">
+              <a:lnSpc>
+                <a:spcPct val="100000"/>
+              </a:lnSpc>
+              <a:spcBef>
+                <a:spcPts val="0"/>
+              </a:spcBef>
+              <a:spcAft>
+                <a:spcPts val="0"/>
+              </a:spcAft>
+              <a:buClr>
+                <a:srgbClr val="000000"/>
+              </a:buClr>
+              <a:buFont typeface="Arial"/>
+              <a:defRPr sz="1400" b="0" i="0" u="none" strike="noStrike" cap="none">
+                <a:solidFill>
+                  <a:srgbClr val="000000"/>
+                </a:solidFill>
+                <a:latin typeface="Arial"/>
+                <a:ea typeface="Arial"/>
+                <a:cs typeface="Arial"/>
+                <a:sym typeface="Arial"/>
+              </a:defRPr>
+            </a:lvl5pPr>
+            <a:lvl6pPr marR="0" lvl="5" algn="l" rtl="0">
+              <a:lnSpc>
+                <a:spcPct val="100000"/>
+              </a:lnSpc>
+              <a:spcBef>
+                <a:spcPts val="0"/>
+              </a:spcBef>
+              <a:spcAft>
+                <a:spcPts val="0"/>
+              </a:spcAft>
+              <a:buClr>
+                <a:srgbClr val="000000"/>
+              </a:buClr>
+              <a:buFont typeface="Arial"/>
+              <a:defRPr sz="1400" b="0" i="0" u="none" strike="noStrike" cap="none">
+                <a:solidFill>
+                  <a:srgbClr val="000000"/>
+                </a:solidFill>
+                <a:latin typeface="Arial"/>
+                <a:ea typeface="Arial"/>
+                <a:cs typeface="Arial"/>
+                <a:sym typeface="Arial"/>
+              </a:defRPr>
+            </a:lvl6pPr>
+            <a:lvl7pPr marR="0" lvl="6" algn="l" rtl="0">
+              <a:lnSpc>
+                <a:spcPct val="100000"/>
+              </a:lnSpc>
+              <a:spcBef>
+                <a:spcPts val="0"/>
+              </a:spcBef>
+              <a:spcAft>
+                <a:spcPts val="0"/>
+              </a:spcAft>
+              <a:buClr>
+                <a:srgbClr val="000000"/>
+              </a:buClr>
+              <a:buFont typeface="Arial"/>
+              <a:defRPr sz="1400" b="0" i="0" u="none" strike="noStrike" cap="none">
+                <a:solidFill>
+                  <a:srgbClr val="000000"/>
+                </a:solidFill>
+                <a:latin typeface="Arial"/>
+                <a:ea typeface="Arial"/>
+                <a:cs typeface="Arial"/>
+                <a:sym typeface="Arial"/>
+              </a:defRPr>
+            </a:lvl7pPr>
+            <a:lvl8pPr marR="0" lvl="7" algn="l" rtl="0">
+              <a:lnSpc>
+                <a:spcPct val="100000"/>
+              </a:lnSpc>
+              <a:spcBef>
+                <a:spcPts val="0"/>
+              </a:spcBef>
+              <a:spcAft>
+                <a:spcPts val="0"/>
+              </a:spcAft>
+              <a:buClr>
+                <a:srgbClr val="000000"/>
+              </a:buClr>
+              <a:buFont typeface="Arial"/>
+              <a:defRPr sz="1400" b="0" i="0" u="none" strike="noStrike" cap="none">
+                <a:solidFill>
+                  <a:srgbClr val="000000"/>
+                </a:solidFill>
+                <a:latin typeface="Arial"/>
+                <a:ea typeface="Arial"/>
+                <a:cs typeface="Arial"/>
+                <a:sym typeface="Arial"/>
+              </a:defRPr>
+            </a:lvl8pPr>
+            <a:lvl9pPr marR="0" lvl="8" algn="l" rtl="0">
+              <a:lnSpc>
+                <a:spcPct val="100000"/>
+              </a:lnSpc>
+              <a:spcBef>
+                <a:spcPts val="0"/>
+              </a:spcBef>
+              <a:spcAft>
+                <a:spcPts val="0"/>
+              </a:spcAft>
+              <a:buClr>
+                <a:srgbClr val="000000"/>
+              </a:buClr>
+              <a:buFont typeface="Arial"/>
+              <a:defRPr sz="1400" b="0" i="0" u="none" strike="noStrike" cap="none">
+                <a:solidFill>
+                  <a:srgbClr val="000000"/>
+                </a:solidFill>
+                <a:latin typeface="Arial"/>
+                <a:ea typeface="Arial"/>
+                <a:cs typeface="Arial"/>
+                <a:sym typeface="Arial"/>
+              </a:defRPr>
+            </a:lvl9pPr>
+          </a:lstStyle>
+          <a:p>
+            <a:pPr marL="0" marR="0" lvl="0" indent="0" algn="r" defTabSz="1219170" rtl="1" eaLnBrk="1" fontAlgn="auto" latinLnBrk="0" hangingPunct="1">
+              <a:lnSpc>
+                <a:spcPct val="100000"/>
+              </a:lnSpc>
+              <a:spcBef>
+                <a:spcPts val="0"/>
+              </a:spcBef>
+              <a:spcAft>
+                <a:spcPts val="0"/>
+              </a:spcAft>
+              <a:buClr>
+                <a:srgbClr val="000000"/>
+              </a:buClr>
+              <a:buSzPts val="1500"/>
+              <a:buFont typeface="Arial"/>
+              <a:buNone/>
+              <a:tabLst/>
+              <a:defRPr/>
+            </a:pPr>
+            <a:r>
+              <a:rPr kumimoji="0" lang="he-IL" sz="2133" b="1" i="0" u="none" strike="noStrike" kern="0" cap="none" spc="0" normalizeH="0" baseline="0" noProof="0" dirty="0">
+                <a:ln>
+                  <a:noFill/>
+                </a:ln>
+                <a:solidFill>
+                  <a:srgbClr val="002F6C"/>
+                </a:solidFill>
+                <a:effectLst/>
+                <a:uLnTx/>
+                <a:uFillTx/>
+                <a:latin typeface="Assistant"/>
+                <a:ea typeface="Assistant"/>
+                <a:cs typeface="Assistant"/>
+                <a:sym typeface="Assistant"/>
+              </a:rPr>
+              <a:t> מכירות –2026  </a:t>
+            </a:r>
+            <a:r>
+              <a:rPr kumimoji="0" lang="he-IL" sz="2400" b="1" i="0" u="none" strike="noStrike" kern="1200" cap="none" spc="0" normalizeH="0" baseline="0" noProof="0" dirty="0">
+                <a:ln>
+                  <a:noFill/>
+                </a:ln>
+                <a:solidFill>
+                  <a:srgbClr val="002F6C"/>
+                </a:solidFill>
+                <a:effectLst/>
+                <a:uLnTx/>
+                <a:uFillTx/>
+                <a:latin typeface="Assistant"/>
+                <a:ea typeface="Assistant"/>
+                <a:cs typeface="Assistant"/>
+                <a:sym typeface="Assistant"/>
+              </a:rPr>
+              <a:t>התפלגות לפי לקוחות  </a:t>
+            </a:r>
+          </a:p>
+        </p:txBody>
+      </p:sp>
+      <p:graphicFrame>
+        <p:nvGraphicFramePr>
+          <p:cNvPr id="3" name="תרשים 2">
+            <a:extLst>
+              <a:ext uri="{FF2B5EF4-FFF2-40B4-BE49-F238E27FC236}">
+                <a16:creationId xmlns:a16="http://schemas.microsoft.com/office/drawing/2014/main" id="{E8D7A057-64CB-B297-FEC2-45B78BEF3B61}"/>
+              </a:ext>
+            </a:extLst>
+          </p:cNvPr>
+          <p:cNvGraphicFramePr>
+            <a:graphicFrameLocks/>
+          </p:cNvGraphicFramePr>
+          <p:nvPr/>
+        </p:nvGraphicFramePr>
+        <p:xfrm>
+          <a:off x="2688336" y="1197864"/>
+          <a:ext cx="6556248" cy="3758184"/>
+        </p:xfrm>
+        <a:graphic>
+          <a:graphicData uri="http://schemas.openxmlformats.org/drawingml/2006/chart">
+            <c:chart xmlns:c="http://schemas.openxmlformats.org/drawingml/2006/chart" xmlns:r="http://schemas.openxmlformats.org/officeDocument/2006/relationships" r:id="rId3"/>
+          </a:graphicData>
+        </a:graphic>
+      </p:graphicFrame>
+    </p:spTree>
+    <p:extLst>
+      <p:ext uri="{BB962C8B-B14F-4D97-AF65-F5344CB8AC3E}">
+        <p14:creationId xmlns:p14="http://schemas.microsoft.com/office/powerpoint/2010/main" val="845718260"/>
       </p:ext>
     </p:extLst>
   </p:cSld>

</xml_diff>